<commit_message>
Bloc 4 : harmoniser la rédaction du notebook, du README et de la présentation
Remplacer tirets longs et flèches par une ponctuation classique, retirer les
amorces répétitives ; notebook ré-exécuté (résultats inchangés).

Co-Authored-By: Claude Fable 5.1 <noreply@anthropic.com>
</commit_message>
<xml_diff>
--- a/bloc4-deep-learning/ATT_SpamDetector_Presentation.pptx
+++ b/bloc4-deep-learning/ATT_SpamDetector_Presentation.pptx
@@ -1051,7 +1051,7 @@
           <a:p>
             <a:r>
               <a:rPr lang="en-US" dirty="0"/>
-              <a:t>Phrase de clôture : j'ai transformé du texte brut en nombres, comparé un réseau entraîné de zéro à un modèle pré-entraîné spécialisé, et le transfer learning gagne — plus de spams attrapés pour un coût maîtrisé.</a:t>
+              <a:t>Phrase de clôture : j'ai transformé du texte brut en nombres, comparé un réseau entraîné de zéro à un modèle pré-entraîné spécialisé, et le transfer learning gagne là où ça compte : il ne bloque presque plus jamais un vrai message. Plus de spams attrapés pour un coût maîtrisé.</a:t>
             </a:r>
             <a:endParaRPr lang="en-US" dirty="0"/>
           </a:p>
@@ -1139,7 +1139,7 @@
           <a:p>
             <a:r>
               <a:rPr lang="en-US" dirty="0"/>
-              <a:t>Déséquilibre = LE point méthodo. Accuracy trompeuse. F1 spam = précision (peu de vrais messages bloqués) × rappel (peu de spams ratés). Doublons retirés avant le split pour éviter la fuite train→test.</a:t>
+              <a:t>Déséquilibre = LE point méthodo. Accuracy trompeuse. F1 spam = précision (peu de vrais messages bloqués) × rappel (peu de spams ratés). Doublons retirés avant le split pour éviter la fuite du train vers le test.</a:t>
             </a:r>
             <a:endParaRPr lang="en-US" dirty="0"/>
           </a:p>
@@ -1227,7 +1227,7 @@
           <a:p>
             <a:r>
               <a:rPr lang="en-US" dirty="0"/>
-              <a:t>Analogie : traducteur texte→nombres. Point de rigueur : tokenizer fit sur le train uniquement, sinon fuite de données. Pour DistilBERT on ne nettoie PAS : son propre tokenizer WordPiece exploite chiffres et ponctuation (signaux de spam).</a:t>
+              <a:t>Analogie : traducteur du texte vers les nombres. Point de rigueur : tokenizer fit sur le train uniquement, sinon fuite de données. Pour DistilBERT on ne nettoie PAS : son propre tokenizer WordPiece exploite chiffres et ponctuation (signaux de spam).</a:t>
             </a:r>
             <a:endParaRPr lang="en-US" dirty="0"/>
           </a:p>
@@ -1403,7 +1403,7 @@
           <a:p>
             <a:r>
               <a:rPr lang="en-US" dirty="0"/>
-              <a:t>Baseline = élève débutant qui apprend tout de zéro sur 3 700 SMS. Pourquoi moyenne plutôt que LSTM : présence des mots &gt; ordre, messages courts, rapide. Pourquoi entropie croisée : fonction de coût naturelle d'une sortie probabiliste, pénalise fort une erreur confiante. Même fonction pour DistilBERT (2 logits). Mêmes jeux train/val/test pour les deux → comparaison à données égales.</a:t>
+              <a:t>Baseline = élève débutant qui apprend tout de zéro sur 3 700 SMS. Pourquoi moyenne plutôt que LSTM : présence des mots &gt; ordre, messages courts, rapide. Pourquoi entropie croisée : fonction de coût naturelle d'une sortie probabiliste, pénalise fort une erreur confiante. Même fonction pour DistilBERT (2 logits). Mêmes jeux train/val/test pour les deux, donc comparaison à données égales.</a:t>
             </a:r>
             <a:endParaRPr lang="en-US" dirty="0"/>
           </a:p>
@@ -1667,7 +1667,7 @@
           <a:p>
             <a:r>
               <a:rPr lang="en-US" dirty="0"/>
-              <a:t>Relance fréquente : précision ou rappel ? → dépend du coût métier. Ici FP plus grave → seuil &gt; 0,5, réglé sur la validation (jamais sur le test). Montrer les SMS mal classés prouve qu'on a regardé les données, pas seulement les scores.</a:t>
+              <a:t>Relance fréquente : précision ou rappel ? Dépend du coût métier. Ici FP plus grave, donc seuil &gt; 0,5, réglé sur la validation (jamais sur le test). Montrer les SMS mal classés prouve qu'on a regardé les données, pas seulement les scores.</a:t>
             </a:r>
             <a:endParaRPr lang="en-US" dirty="0"/>
           </a:p>
@@ -1755,7 +1755,7 @@
           <a:p>
             <a:r>
               <a:rPr lang="en-US" dirty="0"/>
-              <a:t>POC. Dérive = les données changent, le modèle figé se dégrade → monitoring. Pas d'augmentation de données utilisée : le jeu suffit ; possible via synonymes / rétro-traduction sur la classe spam.</a:t>
+              <a:t>POC. Dérive = les données changent, le modèle figé se dégrade, donc monitoring. Pas d'augmentation de données utilisée : le jeu suffit ; possible via synonymes / rétro-traduction sur la classe spam.</a:t>
             </a:r>
             <a:endParaRPr lang="en-US" dirty="0"/>
           </a:p>
@@ -2239,7 +2239,7 @@
                 <a:ea typeface="Calibri" pitchFamily="34" charset="-122"/>
                 <a:cs typeface="Calibri" pitchFamily="34" charset="-120"/>
               </a:rPr>
-              <a:t>Classer chaque SMS — légitime ou spam — à partir du texte seul.</a:t>
+              <a:t>Classer chaque SMS, légitime ou spam, à partir du texte seul.</a:t>
             </a:r>
             <a:endParaRPr lang="en-US" sz="1600" dirty="0"/>
           </a:p>
@@ -2512,7 +2512,7 @@
                 <a:ea typeface="Calibri" pitchFamily="34" charset="-122"/>
                 <a:cs typeface="Calibri" pitchFamily="34" charset="-120"/>
               </a:rPr>
-              <a:t>Marine Deldicque   ·   Jedha Data Science   ·   Certification CDSD — Bloc 4</a:t>
+              <a:t>Marine Deldicque   ·   Jedha Data Science   ·   Certification CDSD, Bloc 4</a:t>
             </a:r>
             <a:endParaRPr lang="en-US" sz="900" dirty="0"/>
           </a:p>
@@ -2686,7 +2686,7 @@
                 <a:ea typeface="Calibri" pitchFamily="34" charset="-122"/>
                 <a:cs typeface="Calibri" pitchFamily="34" charset="-120"/>
               </a:rPr>
-              <a:t>Données déséquilibrées  —  </a:t>
+              <a:t>Données déséquilibrées :  </a:t>
             </a:r>
             <a:pPr indent="0" marL="0">
               <a:buNone/>
@@ -2700,7 +2700,7 @@
                 <a:ea typeface="Calibri" pitchFamily="34" charset="-122"/>
                 <a:cs typeface="Calibri" pitchFamily="34" charset="-120"/>
               </a:rPr>
-              <a:t>87 % légitimes / 13 % spams, doublons retirés — on suit le F1 du spam, pas l'accuracy.</a:t>
+              <a:t>87 % légitimes / 13 % spams, doublons retirés. On suit le F1 du spam, pas l'accuracy.</a:t>
             </a:r>
             <a:endParaRPr lang="en-US" sz="1400" dirty="0"/>
           </a:p>
@@ -2764,7 +2764,7 @@
                 <a:ea typeface="Calibri" pitchFamily="34" charset="-122"/>
                 <a:cs typeface="Calibri" pitchFamily="34" charset="-120"/>
               </a:rPr>
-              <a:t>Texte transformé en nombres  —  </a:t>
+              <a:t>Texte transformé en nombres :  </a:t>
             </a:r>
             <a:pPr indent="0" marL="0">
               <a:buNone/>
@@ -2842,7 +2842,7 @@
                 <a:ea typeface="Calibri" pitchFamily="34" charset="-122"/>
                 <a:cs typeface="Calibri" pitchFamily="34" charset="-120"/>
               </a:rPr>
-              <a:t>Deux modèles, mêmes données  —  </a:t>
+              <a:t>Deux modèles, mêmes données :  </a:t>
             </a:r>
             <a:pPr indent="0" marL="0">
               <a:buNone/>
@@ -2920,7 +2920,7 @@
                 <a:ea typeface="Calibri" pitchFamily="34" charset="-122"/>
                 <a:cs typeface="Calibri" pitchFamily="34" charset="-120"/>
               </a:rPr>
-              <a:t>Recommandation  —  </a:t>
+              <a:t>Recommandation :  </a:t>
             </a:r>
             <a:pPr indent="0" marL="0">
               <a:buNone/>
@@ -3317,7 +3317,7 @@
                 <a:ea typeface="Calibri" pitchFamily="34" charset="-122"/>
                 <a:cs typeface="Calibri" pitchFamily="34" charset="-120"/>
               </a:rPr>
-              <a:t>5 572 SMS étiquetés · 403 doublons retirés → 5 169 uniques</a:t>
+              <a:t>5 572 SMS étiquetés · 403 doublons retirés, 5 169 uniques</a:t>
             </a:r>
             <a:endParaRPr lang="en-US" sz="1250" dirty="0"/>
           </a:p>
@@ -3519,7 +3519,7 @@
                 <a:ea typeface="Calibri" pitchFamily="34" charset="-122"/>
                 <a:cs typeface="Calibri" pitchFamily="34" charset="-120"/>
               </a:rPr>
-              <a:t>87 % ham / 13 % spam → pondération de la classe spam</a:t>
+              <a:t>87 % ham / 13 % spam, classe spam pondérée</a:t>
             </a:r>
             <a:endParaRPr lang="en-US" sz="1250" dirty="0"/>
           </a:p>
@@ -5254,7 +5254,7 @@
                 <a:ea typeface="Calibri" pitchFamily="34" charset="-122"/>
                 <a:cs typeface="Calibri" pitchFamily="34" charset="-120"/>
               </a:rPr>
-              <a:t>chaque mot → 32 nombres réels (10 000 mots × 32 = la matrice d'embedding)</a:t>
+              <a:t>chaque mot devient 32 nombres réels (10 000 mots × 32 = la matrice d'embedding)</a:t>
             </a:r>
             <a:endParaRPr lang="en-US" sz="1300" dirty="0"/>
           </a:p>
@@ -5410,7 +5410,7 @@
                 <a:ea typeface="Calibri" pitchFamily="34" charset="-122"/>
                 <a:cs typeface="Calibri" pitchFamily="34" charset="-120"/>
               </a:rPr>
-              <a:t>mots proches dans l'espace → rôle similaire dans la décision</a:t>
+              <a:t>mots proches dans l'espace = rôle similaire dans la décision</a:t>
             </a:r>
             <a:endParaRPr lang="en-US" sz="1300" dirty="0"/>
           </a:p>
@@ -5527,7 +5527,7 @@
                 <a:ea typeface="Calibri" pitchFamily="34" charset="-122"/>
                 <a:cs typeface="Calibri" pitchFamily="34" charset="-120"/>
               </a:rPr>
-              <a:t>Vérifié dans le notebook (plus proches voisins, cosinus) : « prize » → urgent, txt, mobile, stop ; « ok » → going, said, sorry, still. Le jeton « £ » (montants) ressort aussi côté spam.</a:t>
+              <a:t>Vérifié dans le notebook (plus proches voisins, cosinus) : « prize » est proche de urgent, txt, mobile, stop ; « ok » de going, said, sorry, still. Le jeton « £ » (montants) ressort aussi côté spam.</a:t>
             </a:r>
             <a:endParaRPr lang="en-US" sz="1100" dirty="0"/>
           </a:p>
@@ -6952,7 +6952,7 @@
                 <a:ea typeface="Calibri" pitchFamily="34" charset="-122"/>
                 <a:cs typeface="Calibri" pitchFamily="34" charset="-120"/>
               </a:rPr>
-              <a:t>MODÈLE 1 — DE RÉFÉRENCE (BASELINE)</a:t>
+              <a:t>MODÈLE 1 · DE RÉFÉRENCE (BASELINE)</a:t>
             </a:r>
             <a:endParaRPr lang="en-US" sz="1200" dirty="0"/>
           </a:p>
@@ -7069,7 +7069,7 @@
                 <a:ea typeface="Calibri" pitchFamily="34" charset="-122"/>
                 <a:cs typeface="Calibri" pitchFamily="34" charset="-120"/>
               </a:rPr>
-              <a:t>chaque mot → vecteur appris de zéro</a:t>
+              <a:t>un vecteur appris de zéro par mot</a:t>
             </a:r>
             <a:endParaRPr lang="en-US" sz="1250" dirty="0"/>
           </a:p>
@@ -7516,7 +7516,7 @@
                 <a:ea typeface="Calibri" pitchFamily="34" charset="-122"/>
                 <a:cs typeface="Calibri" pitchFamily="34" charset="-120"/>
               </a:rPr>
-              <a:t>MODÈLE 2 — PRÉ-ENTRAÎNÉ (TRANSFER LEARNING)</a:t>
+              <a:t>MODÈLE 2 · PRÉ-ENTRAÎNÉ (TRANSFER LEARNING)</a:t>
             </a:r>
             <a:endParaRPr lang="en-US" sz="1200" dirty="0"/>
           </a:p>
@@ -7867,7 +7867,7 @@
                 <a:ea typeface="Calibri" pitchFamily="34" charset="-122"/>
                 <a:cs typeface="Calibri" pitchFamily="34" charset="-120"/>
               </a:rPr>
-              <a:t>2 logits → softmax → probabilité de spam</a:t>
+              <a:t>2 logits, softmax, probabilité de spam</a:t>
             </a:r>
             <a:endParaRPr lang="en-US" sz="1250" dirty="0"/>
           </a:p>
@@ -9227,7 +9227,7 @@
                 <a:ea typeface="Calibri" pitchFamily="34" charset="-122"/>
                 <a:cs typeface="Calibri" pitchFamily="34" charset="-120"/>
               </a:rPr>
-              <a:t>F1 du spam sur le jeu de test — plus c'est haut, mieux c'est</a:t>
+              <a:t>F1 du spam sur le jeu de test (plus c'est haut, mieux c'est)</a:t>
             </a:r>
             <a:endParaRPr lang="en-US" sz="1250" dirty="0"/>
           </a:p>

</xml_diff>

<commit_message>
Bloc 4 : présentation structurée en introduction, développement, limites, conclusion ; annexes remplacées par des figures du notebook
Co-Authored-By: Claude Fable 5.1 <noreply@anthropic.com>
</commit_message>
<xml_diff>
--- a/bloc4-deep-learning/ATT_SpamDetector_Presentation.pptx
+++ b/bloc4-deep-learning/ATT_SpamDetector_Presentation.pptx
@@ -1051,7 +1051,7 @@
           <a:p>
             <a:r>
               <a:rPr lang="en-US" dirty="0"/>
-              <a:t>POC. Dérive = les données changent, le modèle figé se dégrade, donc monitoring. Pas d'augmentation de données utilisée : le jeu suffit ; possible via synonymes / rétro-traduction sur la classe spam.</a:t>
+              <a:t>Analogie : diplômé de lettres embauché puis formé 3 jours. Trois étapes : pré-entraînement (masques), tête de classification, ajustement fin de tout le réseau. Figures du notebook (section 6.3). Alternative : geler l'encodeur, moins cher, moins performant.</a:t>
             </a:r>
             <a:endParaRPr lang="en-US" dirty="0"/>
           </a:p>
@@ -1579,7 +1579,7 @@
           <a:p>
             <a:r>
               <a:rPr lang="en-US" dirty="0"/>
-              <a:t>Phrase de clôture : j'ai transformé du texte brut en nombres, comparé un réseau entraîné de zéro à un modèle pré-entraîné spécialisé, et le transfer learning gagne là où ça compte : il ne bloque presque plus jamais un vrai message. Plus de spams attrapés pour un coût maîtrisé.</a:t>
+              <a:t>POC. Dérive = les données changent, le modèle figé se dégrade, donc monitoring. Pas d'augmentation de données utilisée : le jeu suffit ; possible via synonymes / rétro-traduction sur la classe spam.</a:t>
             </a:r>
             <a:endParaRPr lang="en-US" dirty="0"/>
           </a:p>
@@ -1667,7 +1667,7 @@
           <a:p>
             <a:r>
               <a:rPr lang="en-US" dirty="0"/>
-              <a:t>Analogie GPS : tokenisation = matricule (identité), embedding = coordonnées dans un espace de sens. Définition : vecteur dense de réels, distance = similarité de rôle. Appris par rétropropagation comme les autres poids. Dans BERT, contextuel grâce à l'attention.</a:t>
+              <a:t>Phrase de clôture : j'ai transformé du texte brut en nombres, comparé un réseau entraîné de zéro à un modèle pré-entraîné spécialisé, et le transfer learning gagne là où ça compte : il ne bloque presque plus jamais un vrai message. Plus de spams attrapés pour un coût maîtrisé.</a:t>
             </a:r>
             <a:endParaRPr lang="en-US" dirty="0"/>
           </a:p>
@@ -1755,7 +1755,7 @@
           <a:p>
             <a:r>
               <a:rPr lang="en-US" dirty="0"/>
-              <a:t>Analogie : diplômé de lettres embauché puis formé 2 jours sur nos spams. Petit learning rate = ne pas écraser ce qu'il sait (catastrophic forgetting). Alternative moins chère : geler l'encodeur, n'entraîner que la tête. Distillation = élève imite le professeur BERT.</a:t>
+              <a:t>Analogie GPS : le numéro de jeton est un matricule, l'embedding des coordonnées dans un espace de sens. Matrice 10 000 x 32 apprise par rétropropagation. La figure vient du notebook (section 5) : les mots du spam se regroupent à gauche, ceux du quotidien à droite.</a:t>
             </a:r>
             <a:endParaRPr lang="en-US" dirty="0"/>
           </a:p>
@@ -2583,7 +2583,7 @@
                 <a:ea typeface="Calibri" pitchFamily="34" charset="-122"/>
                 <a:cs typeface="Calibri" pitchFamily="34" charset="-120"/>
               </a:rPr>
-              <a:t>ANNEXE · LIMITES</a:t>
+              <a:t>ANNEXE · PREUVE · MODÈLE 2</a:t>
             </a:r>
             <a:endParaRPr lang="en-US" sz="1200" dirty="0"/>
           </a:p>
@@ -2622,7 +2622,7 @@
                 <a:ea typeface="Cambria" pitchFamily="34" charset="-122"/>
                 <a:cs typeface="Cambria" pitchFamily="34" charset="-120"/>
               </a:rPr>
-              <a:t>Ce que le modèle ne sait pas encore faire</a:t>
+              <a:t>Ce que le fine-tuning a changé, epoch par epoch</a:t>
             </a:r>
             <a:endParaRPr lang="en-US" sz="3000" dirty="0"/>
           </a:p>
@@ -2700,7 +2700,7 @@
                 <a:ea typeface="Calibri" pitchFamily="34" charset="-122"/>
                 <a:cs typeface="Calibri" pitchFamily="34" charset="-120"/>
               </a:rPr>
-              <a:t>Annexe 3</a:t>
+              <a:t>Annexe 2</a:t>
             </a:r>
             <a:endParaRPr lang="en-US" sz="900" dirty="0"/>
           </a:p>
@@ -2714,12 +2714,12 @@
         </p:nvSpPr>
         <p:spPr>
           <a:xfrm>
-            <a:off x="777240" y="1783080"/>
-            <a:ext cx="5166360" cy="1874520"/>
+            <a:off x="777240" y="1691640"/>
+            <a:ext cx="10607040" cy="2880360"/>
           </a:xfrm>
           <a:prstGeom prst="roundRect">
             <a:avLst>
-              <a:gd name="adj" fmla="val 5854"/>
+              <a:gd name="adj" fmla="val 3810"/>
             </a:avLst>
           </a:prstGeom>
           <a:solidFill>
@@ -2742,121 +2742,81 @@
       </p:sp>
       <p:sp>
         <p:nvSpPr>
-          <p:cNvPr id="7" name="Shape 5"/>
+          <p:cNvPr id="7" name="Text 5"/>
+          <p:cNvSpPr txBox="1"/>
+          <p:nvPr/>
+        </p:nvSpPr>
+        <p:spPr>
+          <a:xfrm>
+            <a:off x="1097280" y="1874520"/>
+            <a:ext cx="10058400" cy="320040"/>
+          </a:xfrm>
+          <a:prstGeom prst="rect">
+            <a:avLst/>
+          </a:prstGeom>
+          <a:noFill/>
+          <a:ln/>
+        </p:spPr>
+        <p:txBody>
+          <a:bodyPr wrap="square" lIns="0" tIns="0" rIns="0" bIns="0" rtlCol="0" anchor="ctr"/>
+          <a:lstStyle/>
+          <a:p>
+            <a:pPr indent="0" marL="0">
+              <a:buNone/>
+            </a:pPr>
+            <a:r>
+              <a:rPr lang="en-US" sz="1200" b="1" dirty="0">
+                <a:solidFill>
+                  <a:srgbClr val="8A847A"/>
+                </a:solidFill>
+                <a:latin typeface="Calibri" pitchFamily="34" charset="0"/>
+                <a:ea typeface="Calibri" pitchFamily="34" charset="-122"/>
+                <a:cs typeface="Calibri" pitchFamily="34" charset="-120"/>
+              </a:rPr>
+              <a:t>DistilBERT : entropie croisée (train / validation) et F1 spam de validation, 3 epochs</a:t>
+            </a:r>
+            <a:endParaRPr lang="en-US" sz="1200" dirty="0"/>
+          </a:p>
+        </p:txBody>
+      </p:sp>
+      <p:pic>
+        <p:nvPicPr>
+          <p:cNvPr id="8" name="Image 0" descr="preencoded.png">    </p:cNvPr>
+          <p:cNvPicPr>
+            <a:picLocks noChangeAspect="1"/>
+          </p:cNvPicPr>
+          <p:nvPr/>
+        </p:nvPicPr>
+        <p:blipFill>
+          <a:blip r:embed="rId1"/>
+          <a:stretch>
+            <a:fillRect/>
+          </a:stretch>
+        </p:blipFill>
+        <p:spPr>
+          <a:xfrm>
+            <a:off x="2440305" y="2240280"/>
+            <a:ext cx="7280910" cy="2240280"/>
+          </a:xfrm>
+          <a:prstGeom prst="rect">
+            <a:avLst/>
+          </a:prstGeom>
+        </p:spPr>
+      </p:pic>
+      <p:sp>
+        <p:nvSpPr>
+          <p:cNvPr id="9" name="Shape 6"/>
           <p:cNvSpPr/>
           <p:nvPr/>
         </p:nvSpPr>
         <p:spPr>
           <a:xfrm>
-            <a:off x="1097280" y="2148840"/>
-            <a:ext cx="146304" cy="146304"/>
-          </a:xfrm>
-          <a:prstGeom prst="ellipse">
-            <a:avLst/>
-          </a:prstGeom>
-          <a:solidFill>
-            <a:srgbClr val="B5503F"/>
-          </a:solidFill>
-          <a:ln w="12700">
-            <a:solidFill>
-              <a:srgbClr val="B5503F"/>
-            </a:solidFill>
-            <a:prstDash val="solid"/>
-          </a:ln>
-        </p:spPr>
-      </p:sp>
-      <p:sp>
-        <p:nvSpPr>
-          <p:cNvPr id="8" name="Text 6"/>
-          <p:cNvSpPr txBox="1"/>
-          <p:nvPr/>
-        </p:nvSpPr>
-        <p:spPr>
-          <a:xfrm>
-            <a:off x="1417320" y="2011680"/>
-            <a:ext cx="4297680" cy="411480"/>
-          </a:xfrm>
-          <a:prstGeom prst="rect">
-            <a:avLst/>
-          </a:prstGeom>
-          <a:noFill/>
-          <a:ln/>
-        </p:spPr>
-        <p:txBody>
-          <a:bodyPr wrap="square" lIns="0" tIns="0" rIns="0" bIns="0" rtlCol="0" anchor="ctr"/>
-          <a:lstStyle/>
-          <a:p>
-            <a:pPr indent="0" marL="0">
-              <a:buNone/>
-            </a:pPr>
-            <a:r>
-              <a:rPr lang="en-US" sz="1600" b="1" dirty="0">
-                <a:solidFill>
-                  <a:srgbClr val="23201C"/>
-                </a:solidFill>
-                <a:latin typeface="Cambria" pitchFamily="34" charset="0"/>
-                <a:ea typeface="Cambria" pitchFamily="34" charset="-122"/>
-                <a:cs typeface="Cambria" pitchFamily="34" charset="-120"/>
-              </a:rPr>
-              <a:t>Petit jeu de données, ancien</a:t>
-            </a:r>
-            <a:endParaRPr lang="en-US" sz="1600" dirty="0"/>
-          </a:p>
-        </p:txBody>
-      </p:sp>
-      <p:sp>
-        <p:nvSpPr>
-          <p:cNvPr id="9" name="Text 7"/>
-          <p:cNvSpPr txBox="1"/>
-          <p:nvPr/>
-        </p:nvSpPr>
-        <p:spPr>
-          <a:xfrm>
-            <a:off x="1417320" y="2514600"/>
-            <a:ext cx="4297680" cy="1005840"/>
-          </a:xfrm>
-          <a:prstGeom prst="rect">
-            <a:avLst/>
-          </a:prstGeom>
-          <a:noFill/>
-          <a:ln/>
-        </p:spPr>
-        <p:txBody>
-          <a:bodyPr wrap="square" lIns="0" tIns="0" rIns="0" bIns="0" rtlCol="0" anchor="t"/>
-          <a:lstStyle/>
-          <a:p>
-            <a:pPr indent="0" marL="0">
-              <a:buNone/>
-            </a:pPr>
-            <a:r>
-              <a:rPr lang="en-US" sz="1200" dirty="0">
-                <a:solidFill>
-                  <a:srgbClr val="8A847A"/>
-                </a:solidFill>
-                <a:latin typeface="Calibri" pitchFamily="34" charset="0"/>
-                <a:ea typeface="Calibri" pitchFamily="34" charset="-122"/>
-                <a:cs typeface="Calibri" pitchFamily="34" charset="-120"/>
-              </a:rPr>
-              <a:t>5 169 SMS uniques (anglais, années 2010) suffisent pour une preuve de concept, pas pour couvrir les spams d'aujourd'hui : emojis, liens raccourcis, contournements.</a:t>
-            </a:r>
-            <a:endParaRPr lang="en-US" sz="1200" dirty="0"/>
-          </a:p>
-        </p:txBody>
-      </p:sp>
-      <p:sp>
-        <p:nvSpPr>
-          <p:cNvPr id="10" name="Shape 8"/>
-          <p:cNvSpPr/>
-          <p:nvPr/>
-        </p:nvSpPr>
-        <p:spPr>
-          <a:xfrm>
-            <a:off x="6217920" y="1783080"/>
-            <a:ext cx="5166360" cy="1874520"/>
+            <a:off x="777240" y="4754880"/>
+            <a:ext cx="3383280" cy="1325880"/>
           </a:xfrm>
           <a:prstGeom prst="roundRect">
             <a:avLst>
-              <a:gd name="adj" fmla="val 5854"/>
+              <a:gd name="adj" fmla="val 8276"/>
             </a:avLst>
           </a:prstGeom>
           <a:solidFill>
@@ -2879,39 +2839,14 @@
       </p:sp>
       <p:sp>
         <p:nvSpPr>
-          <p:cNvPr id="11" name="Shape 9"/>
-          <p:cNvSpPr/>
-          <p:nvPr/>
-        </p:nvSpPr>
-        <p:spPr>
-          <a:xfrm>
-            <a:off x="6537960" y="2148840"/>
-            <a:ext cx="146304" cy="146304"/>
-          </a:xfrm>
-          <a:prstGeom prst="ellipse">
-            <a:avLst/>
-          </a:prstGeom>
-          <a:solidFill>
-            <a:srgbClr val="B5503F"/>
-          </a:solidFill>
-          <a:ln w="12700">
-            <a:solidFill>
-              <a:srgbClr val="B5503F"/>
-            </a:solidFill>
-            <a:prstDash val="solid"/>
-          </a:ln>
-        </p:spPr>
-      </p:sp>
-      <p:sp>
-        <p:nvSpPr>
-          <p:cNvPr id="12" name="Text 10"/>
-          <p:cNvSpPr txBox="1"/>
-          <p:nvPr/>
-        </p:nvSpPr>
-        <p:spPr>
-          <a:xfrm>
-            <a:off x="6858000" y="2011680"/>
-            <a:ext cx="4297680" cy="411480"/>
+          <p:cNvPr id="10" name="Text 7"/>
+          <p:cNvSpPr txBox="1"/>
+          <p:nvPr/>
+        </p:nvSpPr>
+        <p:spPr>
+          <a:xfrm>
+            <a:off x="1051560" y="4846320"/>
+            <a:ext cx="2834640" cy="548640"/>
           </a:xfrm>
           <a:prstGeom prst="rect">
             <a:avLst/>
@@ -2927,30 +2862,30 @@
               <a:buNone/>
             </a:pPr>
             <a:r>
-              <a:rPr lang="en-US" sz="1600" b="1" dirty="0">
-                <a:solidFill>
-                  <a:srgbClr val="23201C"/>
+              <a:rPr lang="en-US" sz="2600" b="1" dirty="0">
+                <a:solidFill>
+                  <a:srgbClr val="B5503F"/>
                 </a:solidFill>
                 <a:latin typeface="Cambria" pitchFamily="34" charset="0"/>
                 <a:ea typeface="Cambria" pitchFamily="34" charset="-122"/>
                 <a:cs typeface="Cambria" pitchFamily="34" charset="-120"/>
               </a:rPr>
-              <a:t>Anglais seulement</a:t>
-            </a:r>
-            <a:endParaRPr lang="en-US" sz="1600" dirty="0"/>
-          </a:p>
-        </p:txBody>
-      </p:sp>
-      <p:sp>
-        <p:nvSpPr>
-          <p:cNvPr id="13" name="Text 11"/>
-          <p:cNvSpPr txBox="1"/>
-          <p:nvPr/>
-        </p:nvSpPr>
-        <p:spPr>
-          <a:xfrm>
-            <a:off x="6858000" y="2514600"/>
-            <a:ext cx="4297680" cy="1005840"/>
+              <a:t>0,96</a:t>
+            </a:r>
+            <a:endParaRPr lang="en-US" sz="2600" dirty="0"/>
+          </a:p>
+        </p:txBody>
+      </p:sp>
+      <p:sp>
+        <p:nvSpPr>
+          <p:cNvPr id="11" name="Text 8"/>
+          <p:cNvSpPr txBox="1"/>
+          <p:nvPr/>
+        </p:nvSpPr>
+        <p:spPr>
+          <a:xfrm>
+            <a:off x="1051560" y="5394960"/>
+            <a:ext cx="2834640" cy="640080"/>
           </a:xfrm>
           <a:prstGeom prst="rect">
             <a:avLst/>
@@ -2966,7 +2901,7 @@
               <a:buNone/>
             </a:pPr>
             <a:r>
-              <a:rPr lang="en-US" sz="1200" dirty="0">
+              <a:rPr lang="en-US" sz="1000" dirty="0">
                 <a:solidFill>
                   <a:srgbClr val="8A847A"/>
                 </a:solidFill>
@@ -2974,26 +2909,26 @@
                 <a:ea typeface="Calibri" pitchFamily="34" charset="-122"/>
                 <a:cs typeface="Calibri" pitchFamily="34" charset="-120"/>
               </a:rPr>
-              <a:t>Le modèle ne marche pas tel quel sur d'autres langues : passer à un DistilBERT multilingue.</a:t>
-            </a:r>
-            <a:endParaRPr lang="en-US" sz="1200" dirty="0"/>
-          </a:p>
-        </p:txBody>
-      </p:sp>
-      <p:sp>
-        <p:nvSpPr>
-          <p:cNvPr id="14" name="Shape 12"/>
+              <a:t>F1 spam de validation dès la 1re epoch : le modèle pré-entraîné comprend la tâche immédiatement</a:t>
+            </a:r>
+            <a:endParaRPr lang="en-US" sz="1000" dirty="0"/>
+          </a:p>
+        </p:txBody>
+      </p:sp>
+      <p:sp>
+        <p:nvSpPr>
+          <p:cNvPr id="12" name="Shape 9"/>
           <p:cNvSpPr/>
           <p:nvPr/>
         </p:nvSpPr>
         <p:spPr>
           <a:xfrm>
-            <a:off x="777240" y="3886200"/>
-            <a:ext cx="5166360" cy="1874520"/>
+            <a:off x="4389120" y="4754880"/>
+            <a:ext cx="3383280" cy="1325880"/>
           </a:xfrm>
           <a:prstGeom prst="roundRect">
             <a:avLst>
-              <a:gd name="adj" fmla="val 5854"/>
+              <a:gd name="adj" fmla="val 8276"/>
             </a:avLst>
           </a:prstGeom>
           <a:solidFill>
@@ -3016,39 +2951,14 @@
       </p:sp>
       <p:sp>
         <p:nvSpPr>
-          <p:cNvPr id="15" name="Shape 13"/>
-          <p:cNvSpPr/>
-          <p:nvPr/>
-        </p:nvSpPr>
-        <p:spPr>
-          <a:xfrm>
-            <a:off x="1097280" y="4251960"/>
-            <a:ext cx="146304" cy="146304"/>
-          </a:xfrm>
-          <a:prstGeom prst="ellipse">
-            <a:avLst/>
-          </a:prstGeom>
-          <a:solidFill>
-            <a:srgbClr val="B5503F"/>
-          </a:solidFill>
-          <a:ln w="12700">
-            <a:solidFill>
-              <a:srgbClr val="B5503F"/>
-            </a:solidFill>
-            <a:prstDash val="solid"/>
-          </a:ln>
-        </p:spPr>
-      </p:sp>
-      <p:sp>
-        <p:nvSpPr>
-          <p:cNvPr id="16" name="Text 14"/>
-          <p:cNvSpPr txBox="1"/>
-          <p:nvPr/>
-        </p:nvSpPr>
-        <p:spPr>
-          <a:xfrm>
-            <a:off x="1417320" y="4114800"/>
-            <a:ext cx="4297680" cy="411480"/>
+          <p:cNvPr id="13" name="Text 10"/>
+          <p:cNvSpPr txBox="1"/>
+          <p:nvPr/>
+        </p:nvSpPr>
+        <p:spPr>
+          <a:xfrm>
+            <a:off x="4663440" y="4846320"/>
+            <a:ext cx="2834640" cy="548640"/>
           </a:xfrm>
           <a:prstGeom prst="rect">
             <a:avLst/>
@@ -3064,30 +2974,30 @@
               <a:buNone/>
             </a:pPr>
             <a:r>
-              <a:rPr lang="en-US" sz="1600" b="1" dirty="0">
-                <a:solidFill>
-                  <a:srgbClr val="23201C"/>
+              <a:rPr lang="en-US" sz="2600" b="1" dirty="0">
+                <a:solidFill>
+                  <a:srgbClr val="B5503F"/>
                 </a:solidFill>
                 <a:latin typeface="Cambria" pitchFamily="34" charset="0"/>
                 <a:ea typeface="Cambria" pitchFamily="34" charset="-122"/>
                 <a:cs typeface="Cambria" pitchFamily="34" charset="-120"/>
               </a:rPr>
-              <a:t>Le spam évolue</a:t>
-            </a:r>
-            <a:endParaRPr lang="en-US" sz="1600" dirty="0"/>
-          </a:p>
-        </p:txBody>
-      </p:sp>
-      <p:sp>
-        <p:nvSpPr>
-          <p:cNvPr id="17" name="Text 15"/>
-          <p:cNvSpPr txBox="1"/>
-          <p:nvPr/>
-        </p:nvSpPr>
-        <p:spPr>
-          <a:xfrm>
-            <a:off x="1417320" y="4617720"/>
-            <a:ext cx="4297680" cy="1005840"/>
+              <a:t>0,971</a:t>
+            </a:r>
+            <a:endParaRPr lang="en-US" sz="2600" dirty="0"/>
+          </a:p>
+        </p:txBody>
+      </p:sp>
+      <p:sp>
+        <p:nvSpPr>
+          <p:cNvPr id="14" name="Text 11"/>
+          <p:cNvSpPr txBox="1"/>
+          <p:nvPr/>
+        </p:nvSpPr>
+        <p:spPr>
+          <a:xfrm>
+            <a:off x="4663440" y="5394960"/>
+            <a:ext cx="2834640" cy="640080"/>
           </a:xfrm>
           <a:prstGeom prst="rect">
             <a:avLst/>
@@ -3103,7 +3013,7 @@
               <a:buNone/>
             </a:pPr>
             <a:r>
-              <a:rPr lang="en-US" sz="1200" dirty="0">
+              <a:rPr lang="en-US" sz="1000" dirty="0">
                 <a:solidFill>
                   <a:srgbClr val="8A847A"/>
                 </a:solidFill>
@@ -3111,26 +3021,26 @@
                 <a:ea typeface="Calibri" pitchFamily="34" charset="-122"/>
                 <a:cs typeface="Calibri" pitchFamily="34" charset="-120"/>
               </a:rPr>
-              <a:t>Sans suivi de dérive et réentraînement périodique, le modèle vieillit et se dégrade.</a:t>
-            </a:r>
-            <a:endParaRPr lang="en-US" sz="1200" dirty="0"/>
-          </a:p>
-        </p:txBody>
-      </p:sp>
-      <p:sp>
-        <p:nvSpPr>
-          <p:cNvPr id="18" name="Shape 16"/>
+              <a:t>F1 de validation à la 3e epoch, retenue. Au-delà, la perte train baisse mais la validation stagne</a:t>
+            </a:r>
+            <a:endParaRPr lang="en-US" sz="1000" dirty="0"/>
+          </a:p>
+        </p:txBody>
+      </p:sp>
+      <p:sp>
+        <p:nvSpPr>
+          <p:cNvPr id="15" name="Shape 12"/>
           <p:cNvSpPr/>
           <p:nvPr/>
         </p:nvSpPr>
         <p:spPr>
           <a:xfrm>
-            <a:off x="6217920" y="3886200"/>
-            <a:ext cx="5166360" cy="1874520"/>
+            <a:off x="8001000" y="4754880"/>
+            <a:ext cx="3383280" cy="1325880"/>
           </a:xfrm>
           <a:prstGeom prst="roundRect">
             <a:avLst>
-              <a:gd name="adj" fmla="val 5854"/>
+              <a:gd name="adj" fmla="val 8276"/>
             </a:avLst>
           </a:prstGeom>
           <a:solidFill>
@@ -3153,39 +3063,14 @@
       </p:sp>
       <p:sp>
         <p:nvSpPr>
-          <p:cNvPr id="19" name="Shape 17"/>
-          <p:cNvSpPr/>
-          <p:nvPr/>
-        </p:nvSpPr>
-        <p:spPr>
-          <a:xfrm>
-            <a:off x="6537960" y="4251960"/>
-            <a:ext cx="146304" cy="146304"/>
-          </a:xfrm>
-          <a:prstGeom prst="ellipse">
-            <a:avLst/>
-          </a:prstGeom>
-          <a:solidFill>
-            <a:srgbClr val="B5503F"/>
-          </a:solidFill>
-          <a:ln w="12700">
-            <a:solidFill>
-              <a:srgbClr val="B5503F"/>
-            </a:solidFill>
-            <a:prstDash val="solid"/>
-          </a:ln>
-        </p:spPr>
-      </p:sp>
-      <p:sp>
-        <p:nvSpPr>
-          <p:cNvPr id="20" name="Text 18"/>
-          <p:cNvSpPr txBox="1"/>
-          <p:nvPr/>
-        </p:nvSpPr>
-        <p:spPr>
-          <a:xfrm>
-            <a:off x="6858000" y="4114800"/>
-            <a:ext cx="4297680" cy="411480"/>
+          <p:cNvPr id="16" name="Text 13"/>
+          <p:cNvSpPr txBox="1"/>
+          <p:nvPr/>
+        </p:nvSpPr>
+        <p:spPr>
+          <a:xfrm>
+            <a:off x="8275320" y="4846320"/>
+            <a:ext cx="2834640" cy="548640"/>
           </a:xfrm>
           <a:prstGeom prst="rect">
             <a:avLst/>
@@ -3201,30 +3086,30 @@
               <a:buNone/>
             </a:pPr>
             <a:r>
-              <a:rPr lang="en-US" sz="1600" b="1" dirty="0">
-                <a:solidFill>
-                  <a:srgbClr val="23201C"/>
+              <a:rPr lang="en-US" sz="2600" b="1" dirty="0">
+                <a:solidFill>
+                  <a:srgbClr val="B5503F"/>
                 </a:solidFill>
                 <a:latin typeface="Cambria" pitchFamily="34" charset="0"/>
                 <a:ea typeface="Cambria" pitchFamily="34" charset="-122"/>
                 <a:cs typeface="Cambria" pitchFamily="34" charset="-120"/>
               </a:rPr>
-              <a:t>Coût d'inférence</a:t>
-            </a:r>
-            <a:endParaRPr lang="en-US" sz="1600" dirty="0"/>
-          </a:p>
-        </p:txBody>
-      </p:sp>
-      <p:sp>
-        <p:nvSpPr>
-          <p:cNvPr id="21" name="Text 19"/>
-          <p:cNvSpPr txBox="1"/>
-          <p:nvPr/>
-        </p:nvSpPr>
-        <p:spPr>
-          <a:xfrm>
-            <a:off x="6858000" y="4617720"/>
-            <a:ext cx="4297680" cy="1005840"/>
+              <a:t>2e-5</a:t>
+            </a:r>
+            <a:endParaRPr lang="en-US" sz="2600" dirty="0"/>
+          </a:p>
+        </p:txBody>
+      </p:sp>
+      <p:sp>
+        <p:nvSpPr>
+          <p:cNvPr id="17" name="Text 14"/>
+          <p:cNvSpPr txBox="1"/>
+          <p:nvPr/>
+        </p:nvSpPr>
+        <p:spPr>
+          <a:xfrm>
+            <a:off x="8275320" y="5394960"/>
+            <a:ext cx="2834640" cy="640080"/>
           </a:xfrm>
           <a:prstGeom prst="rect">
             <a:avLst/>
@@ -3240,7 +3125,7 @@
               <a:buNone/>
             </a:pPr>
             <a:r>
-              <a:rPr lang="en-US" sz="1200" dirty="0">
+              <a:rPr lang="en-US" sz="1000" dirty="0">
                 <a:solidFill>
                   <a:srgbClr val="8A847A"/>
                 </a:solidFill>
@@ -3248,9 +3133,9 @@
                 <a:ea typeface="Calibri" pitchFamily="34" charset="-122"/>
                 <a:cs typeface="Calibri" pitchFamily="34" charset="-120"/>
               </a:rPr>
-              <a:t>66 M de paramètres pour des millions de SMS : quantification, ou réseau simple en premier filtre et DistilBERT sur les cas incertains.</a:t>
-            </a:r>
-            <a:endParaRPr lang="en-US" sz="1200" dirty="0"/>
+              <a:t>taux d'apprentissage, 50 fois plus petit que pour le modèle 1 : on ajuste sans effacer</a:t>
+            </a:r>
+            <a:endParaRPr lang="en-US" sz="1000" dirty="0"/>
           </a:p>
         </p:txBody>
       </p:sp>
@@ -3319,7 +3204,7 @@
                 <a:ea typeface="Calibri" pitchFamily="34" charset="-122"/>
                 <a:cs typeface="Calibri" pitchFamily="34" charset="-120"/>
               </a:rPr>
-              <a:t>01 · LE PROBLÈME ET LES DONNÉES</a:t>
+              <a:t>INTRODUCTION · LE PROBLÈME ET LES DONNÉES</a:t>
             </a:r>
             <a:endParaRPr lang="en-US" sz="1200" dirty="0"/>
           </a:p>
@@ -3436,7 +3321,7 @@
                 <a:ea typeface="Calibri" pitchFamily="34" charset="-122"/>
                 <a:cs typeface="Calibri" pitchFamily="34" charset="-120"/>
               </a:rPr>
-              <a:t>2 / 7</a:t>
+              <a:t>2 / 8</a:t>
             </a:r>
             <a:endParaRPr lang="en-US" sz="900" dirty="0"/>
           </a:p>
@@ -4179,7 +4064,7 @@
                 <a:ea typeface="Calibri" pitchFamily="34" charset="-122"/>
                 <a:cs typeface="Calibri" pitchFamily="34" charset="-120"/>
               </a:rPr>
-              <a:t>02 · PRÉPARER LE TEXTE</a:t>
+              <a:t>DÉVELOPPEMENT 1/4 · PRÉPARER LE TEXTE</a:t>
             </a:r>
             <a:endParaRPr lang="en-US" sz="1200" dirty="0"/>
           </a:p>
@@ -4296,7 +4181,7 @@
                 <a:ea typeface="Calibri" pitchFamily="34" charset="-122"/>
                 <a:cs typeface="Calibri" pitchFamily="34" charset="-120"/>
               </a:rPr>
-              <a:t>3 / 7</a:t>
+              <a:t>3 / 8</a:t>
             </a:r>
             <a:endParaRPr lang="en-US" sz="900" dirty="0"/>
           </a:p>
@@ -5256,7 +5141,7 @@
                 <a:ea typeface="Calibri" pitchFamily="34" charset="-122"/>
                 <a:cs typeface="Calibri" pitchFamily="34" charset="-120"/>
               </a:rPr>
-              <a:t>03 · LES DEUX MODÈLES</a:t>
+              <a:t>DÉVELOPPEMENT 2/4 · LES DEUX MODÈLES</a:t>
             </a:r>
             <a:endParaRPr lang="en-US" sz="1200" dirty="0"/>
           </a:p>
@@ -5373,7 +5258,7 @@
                 <a:ea typeface="Calibri" pitchFamily="34" charset="-122"/>
                 <a:cs typeface="Calibri" pitchFamily="34" charset="-120"/>
               </a:rPr>
-              <a:t>4 / 7</a:t>
+              <a:t>4 / 8</a:t>
             </a:r>
             <a:endParaRPr lang="en-US" sz="900" dirty="0"/>
           </a:p>
@@ -6572,7 +6457,7 @@
                 <a:ea typeface="Calibri" pitchFamily="34" charset="-122"/>
                 <a:cs typeface="Calibri" pitchFamily="34" charset="-120"/>
               </a:rPr>
-              <a:t>04 · RÉSULTATS</a:t>
+              <a:t>DÉVELOPPEMENT 3/4 · RÉSULTATS</a:t>
             </a:r>
             <a:endParaRPr lang="en-US" sz="1200" dirty="0"/>
           </a:p>
@@ -6689,7 +6574,7 @@
                 <a:ea typeface="Calibri" pitchFamily="34" charset="-122"/>
                 <a:cs typeface="Calibri" pitchFamily="34" charset="-120"/>
               </a:rPr>
-              <a:t>5 / 7</a:t>
+              <a:t>5 / 8</a:t>
             </a:r>
             <a:endParaRPr lang="en-US" sz="900" dirty="0"/>
           </a:p>
@@ -8605,7 +8490,7 @@
                 <a:ea typeface="Calibri" pitchFamily="34" charset="-122"/>
                 <a:cs typeface="Calibri" pitchFamily="34" charset="-120"/>
               </a:rPr>
-              <a:t>05 · DU MODÈLE À LA DÉCISION</a:t>
+              <a:t>DÉVELOPPEMENT 4/4 · DU MODÈLE À LA DÉCISION</a:t>
             </a:r>
             <a:endParaRPr lang="en-US" sz="1200" dirty="0"/>
           </a:p>
@@ -8722,7 +8607,7 @@
                 <a:ea typeface="Calibri" pitchFamily="34" charset="-122"/>
                 <a:cs typeface="Calibri" pitchFamily="34" charset="-120"/>
               </a:rPr>
-              <a:t>6 / 7</a:t>
+              <a:t>6 / 8</a:t>
             </a:r>
             <a:endParaRPr lang="en-US" sz="900" dirty="0"/>
           </a:p>
@@ -10648,6 +10533,742 @@
     <p:bg>
       <p:bgPr>
         <a:solidFill>
+          <a:srgbClr val="FAF7F0"/>
+        </a:solidFill>
+      </p:bgPr>
+    </p:bg>
+    <p:spTree>
+      <p:nvGrpSpPr>
+        <p:cNvPr id="1" name=""/>
+        <p:cNvGrpSpPr/>
+        <p:nvPr/>
+      </p:nvGrpSpPr>
+      <p:grpSpPr>
+        <a:xfrm>
+          <a:off x="0" y="0"/>
+          <a:ext cx="0" cy="0"/>
+          <a:chOff x="0" y="0"/>
+          <a:chExt cx="0" cy="0"/>
+        </a:xfrm>
+      </p:grpSpPr>
+      <p:sp>
+        <p:nvSpPr>
+          <p:cNvPr id="2" name="Text 0"/>
+          <p:cNvSpPr txBox="1"/>
+          <p:nvPr/>
+        </p:nvSpPr>
+        <p:spPr>
+          <a:xfrm>
+            <a:off x="777240" y="502920"/>
+            <a:ext cx="10058400" cy="274320"/>
+          </a:xfrm>
+          <a:prstGeom prst="rect">
+            <a:avLst/>
+          </a:prstGeom>
+          <a:noFill/>
+          <a:ln/>
+        </p:spPr>
+        <p:txBody>
+          <a:bodyPr wrap="square" lIns="0" tIns="0" rIns="0" bIns="0" rtlCol="0" anchor="ctr"/>
+          <a:lstStyle/>
+          <a:p>
+            <a:pPr indent="0" marL="0">
+              <a:buNone/>
+            </a:pPr>
+            <a:r>
+              <a:rPr lang="en-US" sz="1200" b="1" spc="200" kern="0" dirty="0">
+                <a:solidFill>
+                  <a:srgbClr val="B5503F"/>
+                </a:solidFill>
+                <a:latin typeface="Calibri" pitchFamily="34" charset="0"/>
+                <a:ea typeface="Calibri" pitchFamily="34" charset="-122"/>
+                <a:cs typeface="Calibri" pitchFamily="34" charset="-120"/>
+              </a:rPr>
+              <a:t>LIMITES DU PROJET</a:t>
+            </a:r>
+            <a:endParaRPr lang="en-US" sz="1200" dirty="0"/>
+          </a:p>
+        </p:txBody>
+      </p:sp>
+      <p:sp>
+        <p:nvSpPr>
+          <p:cNvPr id="3" name="Text 1"/>
+          <p:cNvSpPr txBox="1"/>
+          <p:nvPr/>
+        </p:nvSpPr>
+        <p:spPr>
+          <a:xfrm>
+            <a:off x="777240" y="777240"/>
+            <a:ext cx="10607040" cy="731520"/>
+          </a:xfrm>
+          <a:prstGeom prst="rect">
+            <a:avLst/>
+          </a:prstGeom>
+          <a:noFill/>
+          <a:ln/>
+        </p:spPr>
+        <p:txBody>
+          <a:bodyPr wrap="square" lIns="0" tIns="0" rIns="0" bIns="0" rtlCol="0" anchor="ctr"/>
+          <a:lstStyle/>
+          <a:p>
+            <a:pPr indent="0" marL="0">
+              <a:buNone/>
+            </a:pPr>
+            <a:r>
+              <a:rPr lang="en-US" sz="3000" b="1" dirty="0">
+                <a:solidFill>
+                  <a:srgbClr val="23201C"/>
+                </a:solidFill>
+                <a:latin typeface="Cambria" pitchFamily="34" charset="0"/>
+                <a:ea typeface="Cambria" pitchFamily="34" charset="-122"/>
+                <a:cs typeface="Cambria" pitchFamily="34" charset="-120"/>
+              </a:rPr>
+              <a:t>Ce que le modèle ne sait pas encore faire</a:t>
+            </a:r>
+            <a:endParaRPr lang="en-US" sz="3000" dirty="0"/>
+          </a:p>
+        </p:txBody>
+      </p:sp>
+      <p:sp>
+        <p:nvSpPr>
+          <p:cNvPr id="4" name="Text 2"/>
+          <p:cNvSpPr txBox="1"/>
+          <p:nvPr/>
+        </p:nvSpPr>
+        <p:spPr>
+          <a:xfrm>
+            <a:off x="777240" y="6400800"/>
+            <a:ext cx="7315200" cy="274320"/>
+          </a:xfrm>
+          <a:prstGeom prst="rect">
+            <a:avLst/>
+          </a:prstGeom>
+          <a:noFill/>
+          <a:ln/>
+        </p:spPr>
+        <p:txBody>
+          <a:bodyPr wrap="square" lIns="0" tIns="0" rIns="0" bIns="0" rtlCol="0" anchor="ctr"/>
+          <a:lstStyle/>
+          <a:p>
+            <a:pPr indent="0" marL="0">
+              <a:buNone/>
+            </a:pPr>
+            <a:r>
+              <a:rPr lang="en-US" sz="900" dirty="0">
+                <a:solidFill>
+                  <a:srgbClr val="8A847A"/>
+                </a:solidFill>
+                <a:latin typeface="Calibri" pitchFamily="34" charset="0"/>
+                <a:ea typeface="Calibri" pitchFamily="34" charset="-122"/>
+                <a:cs typeface="Calibri" pitchFamily="34" charset="-120"/>
+              </a:rPr>
+              <a:t>Marine Deldicque  ·  AT&amp;T Spam Detector  ·  Bloc 4</a:t>
+            </a:r>
+            <a:endParaRPr lang="en-US" sz="900" dirty="0"/>
+          </a:p>
+        </p:txBody>
+      </p:sp>
+      <p:sp>
+        <p:nvSpPr>
+          <p:cNvPr id="5" name="Text 3"/>
+          <p:cNvSpPr txBox="1"/>
+          <p:nvPr/>
+        </p:nvSpPr>
+        <p:spPr>
+          <a:xfrm>
+            <a:off x="9555480" y="6400800"/>
+            <a:ext cx="1828800" cy="274320"/>
+          </a:xfrm>
+          <a:prstGeom prst="rect">
+            <a:avLst/>
+          </a:prstGeom>
+          <a:noFill/>
+          <a:ln/>
+        </p:spPr>
+        <p:txBody>
+          <a:bodyPr wrap="square" lIns="0" tIns="0" rIns="0" bIns="0" rtlCol="0" anchor="ctr"/>
+          <a:lstStyle/>
+          <a:p>
+            <a:pPr algn="r" indent="0" marL="0">
+              <a:buNone/>
+            </a:pPr>
+            <a:r>
+              <a:rPr lang="en-US" sz="900" dirty="0">
+                <a:solidFill>
+                  <a:srgbClr val="8A847A"/>
+                </a:solidFill>
+                <a:latin typeface="Calibri" pitchFamily="34" charset="0"/>
+                <a:ea typeface="Calibri" pitchFamily="34" charset="-122"/>
+                <a:cs typeface="Calibri" pitchFamily="34" charset="-120"/>
+              </a:rPr>
+              <a:t>7 / 8</a:t>
+            </a:r>
+            <a:endParaRPr lang="en-US" sz="900" dirty="0"/>
+          </a:p>
+        </p:txBody>
+      </p:sp>
+      <p:sp>
+        <p:nvSpPr>
+          <p:cNvPr id="6" name="Shape 4"/>
+          <p:cNvSpPr/>
+          <p:nvPr/>
+        </p:nvSpPr>
+        <p:spPr>
+          <a:xfrm>
+            <a:off x="777240" y="1783080"/>
+            <a:ext cx="5166360" cy="1874520"/>
+          </a:xfrm>
+          <a:prstGeom prst="roundRect">
+            <a:avLst>
+              <a:gd name="adj" fmla="val 5854"/>
+            </a:avLst>
+          </a:prstGeom>
+          <a:solidFill>
+            <a:srgbClr val="FFFFFF"/>
+          </a:solidFill>
+          <a:ln w="12700">
+            <a:solidFill>
+              <a:srgbClr val="E4DDD0"/>
+            </a:solidFill>
+            <a:prstDash val="solid"/>
+          </a:ln>
+          <a:effectLst>
+            <a:outerShdw sx="100000" sy="100000" kx="0" ky="0" algn="bl" rotWithShape="0" blurRad="88900" dist="25400" dir="5400000">
+              <a:srgbClr val="000000">
+                <a:alpha val="10000"/>
+              </a:srgbClr>
+            </a:outerShdw>
+          </a:effectLst>
+        </p:spPr>
+      </p:sp>
+      <p:sp>
+        <p:nvSpPr>
+          <p:cNvPr id="7" name="Shape 5"/>
+          <p:cNvSpPr/>
+          <p:nvPr/>
+        </p:nvSpPr>
+        <p:spPr>
+          <a:xfrm>
+            <a:off x="1097280" y="2148840"/>
+            <a:ext cx="146304" cy="146304"/>
+          </a:xfrm>
+          <a:prstGeom prst="ellipse">
+            <a:avLst/>
+          </a:prstGeom>
+          <a:solidFill>
+            <a:srgbClr val="B5503F"/>
+          </a:solidFill>
+          <a:ln w="12700">
+            <a:solidFill>
+              <a:srgbClr val="B5503F"/>
+            </a:solidFill>
+            <a:prstDash val="solid"/>
+          </a:ln>
+        </p:spPr>
+      </p:sp>
+      <p:sp>
+        <p:nvSpPr>
+          <p:cNvPr id="8" name="Text 6"/>
+          <p:cNvSpPr txBox="1"/>
+          <p:nvPr/>
+        </p:nvSpPr>
+        <p:spPr>
+          <a:xfrm>
+            <a:off x="1417320" y="2011680"/>
+            <a:ext cx="4297680" cy="411480"/>
+          </a:xfrm>
+          <a:prstGeom prst="rect">
+            <a:avLst/>
+          </a:prstGeom>
+          <a:noFill/>
+          <a:ln/>
+        </p:spPr>
+        <p:txBody>
+          <a:bodyPr wrap="square" lIns="0" tIns="0" rIns="0" bIns="0" rtlCol="0" anchor="ctr"/>
+          <a:lstStyle/>
+          <a:p>
+            <a:pPr indent="0" marL="0">
+              <a:buNone/>
+            </a:pPr>
+            <a:r>
+              <a:rPr lang="en-US" sz="1600" b="1" dirty="0">
+                <a:solidFill>
+                  <a:srgbClr val="23201C"/>
+                </a:solidFill>
+                <a:latin typeface="Cambria" pitchFamily="34" charset="0"/>
+                <a:ea typeface="Cambria" pitchFamily="34" charset="-122"/>
+                <a:cs typeface="Cambria" pitchFamily="34" charset="-120"/>
+              </a:rPr>
+              <a:t>Petit jeu de données, ancien</a:t>
+            </a:r>
+            <a:endParaRPr lang="en-US" sz="1600" dirty="0"/>
+          </a:p>
+        </p:txBody>
+      </p:sp>
+      <p:sp>
+        <p:nvSpPr>
+          <p:cNvPr id="9" name="Text 7"/>
+          <p:cNvSpPr txBox="1"/>
+          <p:nvPr/>
+        </p:nvSpPr>
+        <p:spPr>
+          <a:xfrm>
+            <a:off x="1417320" y="2514600"/>
+            <a:ext cx="4297680" cy="1005840"/>
+          </a:xfrm>
+          <a:prstGeom prst="rect">
+            <a:avLst/>
+          </a:prstGeom>
+          <a:noFill/>
+          <a:ln/>
+        </p:spPr>
+        <p:txBody>
+          <a:bodyPr wrap="square" lIns="0" tIns="0" rIns="0" bIns="0" rtlCol="0" anchor="t"/>
+          <a:lstStyle/>
+          <a:p>
+            <a:pPr indent="0" marL="0">
+              <a:buNone/>
+            </a:pPr>
+            <a:r>
+              <a:rPr lang="en-US" sz="1200" dirty="0">
+                <a:solidFill>
+                  <a:srgbClr val="8A847A"/>
+                </a:solidFill>
+                <a:latin typeface="Calibri" pitchFamily="34" charset="0"/>
+                <a:ea typeface="Calibri" pitchFamily="34" charset="-122"/>
+                <a:cs typeface="Calibri" pitchFamily="34" charset="-120"/>
+              </a:rPr>
+              <a:t>5 169 SMS uniques (anglais, années 2010) suffisent pour une preuve de concept, pas pour couvrir les spams d'aujourd'hui : emojis, liens raccourcis, contournements.</a:t>
+            </a:r>
+            <a:endParaRPr lang="en-US" sz="1200" dirty="0"/>
+          </a:p>
+        </p:txBody>
+      </p:sp>
+      <p:sp>
+        <p:nvSpPr>
+          <p:cNvPr id="10" name="Shape 8"/>
+          <p:cNvSpPr/>
+          <p:nvPr/>
+        </p:nvSpPr>
+        <p:spPr>
+          <a:xfrm>
+            <a:off x="6217920" y="1783080"/>
+            <a:ext cx="5166360" cy="1874520"/>
+          </a:xfrm>
+          <a:prstGeom prst="roundRect">
+            <a:avLst>
+              <a:gd name="adj" fmla="val 5854"/>
+            </a:avLst>
+          </a:prstGeom>
+          <a:solidFill>
+            <a:srgbClr val="FFFFFF"/>
+          </a:solidFill>
+          <a:ln w="12700">
+            <a:solidFill>
+              <a:srgbClr val="E4DDD0"/>
+            </a:solidFill>
+            <a:prstDash val="solid"/>
+          </a:ln>
+          <a:effectLst>
+            <a:outerShdw sx="100000" sy="100000" kx="0" ky="0" algn="bl" rotWithShape="0" blurRad="88900" dist="25400" dir="5400000">
+              <a:srgbClr val="000000">
+                <a:alpha val="10000"/>
+              </a:srgbClr>
+            </a:outerShdw>
+          </a:effectLst>
+        </p:spPr>
+      </p:sp>
+      <p:sp>
+        <p:nvSpPr>
+          <p:cNvPr id="11" name="Shape 9"/>
+          <p:cNvSpPr/>
+          <p:nvPr/>
+        </p:nvSpPr>
+        <p:spPr>
+          <a:xfrm>
+            <a:off x="6537960" y="2148840"/>
+            <a:ext cx="146304" cy="146304"/>
+          </a:xfrm>
+          <a:prstGeom prst="ellipse">
+            <a:avLst/>
+          </a:prstGeom>
+          <a:solidFill>
+            <a:srgbClr val="B5503F"/>
+          </a:solidFill>
+          <a:ln w="12700">
+            <a:solidFill>
+              <a:srgbClr val="B5503F"/>
+            </a:solidFill>
+            <a:prstDash val="solid"/>
+          </a:ln>
+        </p:spPr>
+      </p:sp>
+      <p:sp>
+        <p:nvSpPr>
+          <p:cNvPr id="12" name="Text 10"/>
+          <p:cNvSpPr txBox="1"/>
+          <p:nvPr/>
+        </p:nvSpPr>
+        <p:spPr>
+          <a:xfrm>
+            <a:off x="6858000" y="2011680"/>
+            <a:ext cx="4297680" cy="411480"/>
+          </a:xfrm>
+          <a:prstGeom prst="rect">
+            <a:avLst/>
+          </a:prstGeom>
+          <a:noFill/>
+          <a:ln/>
+        </p:spPr>
+        <p:txBody>
+          <a:bodyPr wrap="square" lIns="0" tIns="0" rIns="0" bIns="0" rtlCol="0" anchor="ctr"/>
+          <a:lstStyle/>
+          <a:p>
+            <a:pPr indent="0" marL="0">
+              <a:buNone/>
+            </a:pPr>
+            <a:r>
+              <a:rPr lang="en-US" sz="1600" b="1" dirty="0">
+                <a:solidFill>
+                  <a:srgbClr val="23201C"/>
+                </a:solidFill>
+                <a:latin typeface="Cambria" pitchFamily="34" charset="0"/>
+                <a:ea typeface="Cambria" pitchFamily="34" charset="-122"/>
+                <a:cs typeface="Cambria" pitchFamily="34" charset="-120"/>
+              </a:rPr>
+              <a:t>Anglais seulement</a:t>
+            </a:r>
+            <a:endParaRPr lang="en-US" sz="1600" dirty="0"/>
+          </a:p>
+        </p:txBody>
+      </p:sp>
+      <p:sp>
+        <p:nvSpPr>
+          <p:cNvPr id="13" name="Text 11"/>
+          <p:cNvSpPr txBox="1"/>
+          <p:nvPr/>
+        </p:nvSpPr>
+        <p:spPr>
+          <a:xfrm>
+            <a:off x="6858000" y="2514600"/>
+            <a:ext cx="4297680" cy="1005840"/>
+          </a:xfrm>
+          <a:prstGeom prst="rect">
+            <a:avLst/>
+          </a:prstGeom>
+          <a:noFill/>
+          <a:ln/>
+        </p:spPr>
+        <p:txBody>
+          <a:bodyPr wrap="square" lIns="0" tIns="0" rIns="0" bIns="0" rtlCol="0" anchor="t"/>
+          <a:lstStyle/>
+          <a:p>
+            <a:pPr indent="0" marL="0">
+              <a:buNone/>
+            </a:pPr>
+            <a:r>
+              <a:rPr lang="en-US" sz="1200" dirty="0">
+                <a:solidFill>
+                  <a:srgbClr val="8A847A"/>
+                </a:solidFill>
+                <a:latin typeface="Calibri" pitchFamily="34" charset="0"/>
+                <a:ea typeface="Calibri" pitchFamily="34" charset="-122"/>
+                <a:cs typeface="Calibri" pitchFamily="34" charset="-120"/>
+              </a:rPr>
+              <a:t>Le modèle ne marche pas tel quel sur d'autres langues : passer à un DistilBERT multilingue.</a:t>
+            </a:r>
+            <a:endParaRPr lang="en-US" sz="1200" dirty="0"/>
+          </a:p>
+        </p:txBody>
+      </p:sp>
+      <p:sp>
+        <p:nvSpPr>
+          <p:cNvPr id="14" name="Shape 12"/>
+          <p:cNvSpPr/>
+          <p:nvPr/>
+        </p:nvSpPr>
+        <p:spPr>
+          <a:xfrm>
+            <a:off x="777240" y="3886200"/>
+            <a:ext cx="5166360" cy="1874520"/>
+          </a:xfrm>
+          <a:prstGeom prst="roundRect">
+            <a:avLst>
+              <a:gd name="adj" fmla="val 5854"/>
+            </a:avLst>
+          </a:prstGeom>
+          <a:solidFill>
+            <a:srgbClr val="FFFFFF"/>
+          </a:solidFill>
+          <a:ln w="12700">
+            <a:solidFill>
+              <a:srgbClr val="E4DDD0"/>
+            </a:solidFill>
+            <a:prstDash val="solid"/>
+          </a:ln>
+          <a:effectLst>
+            <a:outerShdw sx="100000" sy="100000" kx="0" ky="0" algn="bl" rotWithShape="0" blurRad="88900" dist="25400" dir="5400000">
+              <a:srgbClr val="000000">
+                <a:alpha val="10000"/>
+              </a:srgbClr>
+            </a:outerShdw>
+          </a:effectLst>
+        </p:spPr>
+      </p:sp>
+      <p:sp>
+        <p:nvSpPr>
+          <p:cNvPr id="15" name="Shape 13"/>
+          <p:cNvSpPr/>
+          <p:nvPr/>
+        </p:nvSpPr>
+        <p:spPr>
+          <a:xfrm>
+            <a:off x="1097280" y="4251960"/>
+            <a:ext cx="146304" cy="146304"/>
+          </a:xfrm>
+          <a:prstGeom prst="ellipse">
+            <a:avLst/>
+          </a:prstGeom>
+          <a:solidFill>
+            <a:srgbClr val="B5503F"/>
+          </a:solidFill>
+          <a:ln w="12700">
+            <a:solidFill>
+              <a:srgbClr val="B5503F"/>
+            </a:solidFill>
+            <a:prstDash val="solid"/>
+          </a:ln>
+        </p:spPr>
+      </p:sp>
+      <p:sp>
+        <p:nvSpPr>
+          <p:cNvPr id="16" name="Text 14"/>
+          <p:cNvSpPr txBox="1"/>
+          <p:nvPr/>
+        </p:nvSpPr>
+        <p:spPr>
+          <a:xfrm>
+            <a:off x="1417320" y="4114800"/>
+            <a:ext cx="4297680" cy="411480"/>
+          </a:xfrm>
+          <a:prstGeom prst="rect">
+            <a:avLst/>
+          </a:prstGeom>
+          <a:noFill/>
+          <a:ln/>
+        </p:spPr>
+        <p:txBody>
+          <a:bodyPr wrap="square" lIns="0" tIns="0" rIns="0" bIns="0" rtlCol="0" anchor="ctr"/>
+          <a:lstStyle/>
+          <a:p>
+            <a:pPr indent="0" marL="0">
+              <a:buNone/>
+            </a:pPr>
+            <a:r>
+              <a:rPr lang="en-US" sz="1600" b="1" dirty="0">
+                <a:solidFill>
+                  <a:srgbClr val="23201C"/>
+                </a:solidFill>
+                <a:latin typeface="Cambria" pitchFamily="34" charset="0"/>
+                <a:ea typeface="Cambria" pitchFamily="34" charset="-122"/>
+                <a:cs typeface="Cambria" pitchFamily="34" charset="-120"/>
+              </a:rPr>
+              <a:t>Le spam évolue</a:t>
+            </a:r>
+            <a:endParaRPr lang="en-US" sz="1600" dirty="0"/>
+          </a:p>
+        </p:txBody>
+      </p:sp>
+      <p:sp>
+        <p:nvSpPr>
+          <p:cNvPr id="17" name="Text 15"/>
+          <p:cNvSpPr txBox="1"/>
+          <p:nvPr/>
+        </p:nvSpPr>
+        <p:spPr>
+          <a:xfrm>
+            <a:off x="1417320" y="4617720"/>
+            <a:ext cx="4297680" cy="1005840"/>
+          </a:xfrm>
+          <a:prstGeom prst="rect">
+            <a:avLst/>
+          </a:prstGeom>
+          <a:noFill/>
+          <a:ln/>
+        </p:spPr>
+        <p:txBody>
+          <a:bodyPr wrap="square" lIns="0" tIns="0" rIns="0" bIns="0" rtlCol="0" anchor="t"/>
+          <a:lstStyle/>
+          <a:p>
+            <a:pPr indent="0" marL="0">
+              <a:buNone/>
+            </a:pPr>
+            <a:r>
+              <a:rPr lang="en-US" sz="1200" dirty="0">
+                <a:solidFill>
+                  <a:srgbClr val="8A847A"/>
+                </a:solidFill>
+                <a:latin typeface="Calibri" pitchFamily="34" charset="0"/>
+                <a:ea typeface="Calibri" pitchFamily="34" charset="-122"/>
+                <a:cs typeface="Calibri" pitchFamily="34" charset="-120"/>
+              </a:rPr>
+              <a:t>Sans suivi de dérive et réentraînement périodique, le modèle vieillit et se dégrade.</a:t>
+            </a:r>
+            <a:endParaRPr lang="en-US" sz="1200" dirty="0"/>
+          </a:p>
+        </p:txBody>
+      </p:sp>
+      <p:sp>
+        <p:nvSpPr>
+          <p:cNvPr id="18" name="Shape 16"/>
+          <p:cNvSpPr/>
+          <p:nvPr/>
+        </p:nvSpPr>
+        <p:spPr>
+          <a:xfrm>
+            <a:off x="6217920" y="3886200"/>
+            <a:ext cx="5166360" cy="1874520"/>
+          </a:xfrm>
+          <a:prstGeom prst="roundRect">
+            <a:avLst>
+              <a:gd name="adj" fmla="val 5854"/>
+            </a:avLst>
+          </a:prstGeom>
+          <a:solidFill>
+            <a:srgbClr val="FFFFFF"/>
+          </a:solidFill>
+          <a:ln w="12700">
+            <a:solidFill>
+              <a:srgbClr val="E4DDD0"/>
+            </a:solidFill>
+            <a:prstDash val="solid"/>
+          </a:ln>
+          <a:effectLst>
+            <a:outerShdw sx="100000" sy="100000" kx="0" ky="0" algn="bl" rotWithShape="0" blurRad="88900" dist="25400" dir="5400000">
+              <a:srgbClr val="000000">
+                <a:alpha val="10000"/>
+              </a:srgbClr>
+            </a:outerShdw>
+          </a:effectLst>
+        </p:spPr>
+      </p:sp>
+      <p:sp>
+        <p:nvSpPr>
+          <p:cNvPr id="19" name="Shape 17"/>
+          <p:cNvSpPr/>
+          <p:nvPr/>
+        </p:nvSpPr>
+        <p:spPr>
+          <a:xfrm>
+            <a:off x="6537960" y="4251960"/>
+            <a:ext cx="146304" cy="146304"/>
+          </a:xfrm>
+          <a:prstGeom prst="ellipse">
+            <a:avLst/>
+          </a:prstGeom>
+          <a:solidFill>
+            <a:srgbClr val="B5503F"/>
+          </a:solidFill>
+          <a:ln w="12700">
+            <a:solidFill>
+              <a:srgbClr val="B5503F"/>
+            </a:solidFill>
+            <a:prstDash val="solid"/>
+          </a:ln>
+        </p:spPr>
+      </p:sp>
+      <p:sp>
+        <p:nvSpPr>
+          <p:cNvPr id="20" name="Text 18"/>
+          <p:cNvSpPr txBox="1"/>
+          <p:nvPr/>
+        </p:nvSpPr>
+        <p:spPr>
+          <a:xfrm>
+            <a:off x="6858000" y="4114800"/>
+            <a:ext cx="4297680" cy="411480"/>
+          </a:xfrm>
+          <a:prstGeom prst="rect">
+            <a:avLst/>
+          </a:prstGeom>
+          <a:noFill/>
+          <a:ln/>
+        </p:spPr>
+        <p:txBody>
+          <a:bodyPr wrap="square" lIns="0" tIns="0" rIns="0" bIns="0" rtlCol="0" anchor="ctr"/>
+          <a:lstStyle/>
+          <a:p>
+            <a:pPr indent="0" marL="0">
+              <a:buNone/>
+            </a:pPr>
+            <a:r>
+              <a:rPr lang="en-US" sz="1600" b="1" dirty="0">
+                <a:solidFill>
+                  <a:srgbClr val="23201C"/>
+                </a:solidFill>
+                <a:latin typeface="Cambria" pitchFamily="34" charset="0"/>
+                <a:ea typeface="Cambria" pitchFamily="34" charset="-122"/>
+                <a:cs typeface="Cambria" pitchFamily="34" charset="-120"/>
+              </a:rPr>
+              <a:t>Coût d'inférence</a:t>
+            </a:r>
+            <a:endParaRPr lang="en-US" sz="1600" dirty="0"/>
+          </a:p>
+        </p:txBody>
+      </p:sp>
+      <p:sp>
+        <p:nvSpPr>
+          <p:cNvPr id="21" name="Text 19"/>
+          <p:cNvSpPr txBox="1"/>
+          <p:nvPr/>
+        </p:nvSpPr>
+        <p:spPr>
+          <a:xfrm>
+            <a:off x="6858000" y="4617720"/>
+            <a:ext cx="4297680" cy="1005840"/>
+          </a:xfrm>
+          <a:prstGeom prst="rect">
+            <a:avLst/>
+          </a:prstGeom>
+          <a:noFill/>
+          <a:ln/>
+        </p:spPr>
+        <p:txBody>
+          <a:bodyPr wrap="square" lIns="0" tIns="0" rIns="0" bIns="0" rtlCol="0" anchor="t"/>
+          <a:lstStyle/>
+          <a:p>
+            <a:pPr indent="0" marL="0">
+              <a:buNone/>
+            </a:pPr>
+            <a:r>
+              <a:rPr lang="en-US" sz="1200" dirty="0">
+                <a:solidFill>
+                  <a:srgbClr val="8A847A"/>
+                </a:solidFill>
+                <a:latin typeface="Calibri" pitchFamily="34" charset="0"/>
+                <a:ea typeface="Calibri" pitchFamily="34" charset="-122"/>
+                <a:cs typeface="Calibri" pitchFamily="34" charset="-120"/>
+              </a:rPr>
+              <a:t>67 M de paramètres pour des millions de SMS : quantification, ou réseau simple en premier filtre et DistilBERT sur les cas incertains.</a:t>
+            </a:r>
+            <a:endParaRPr lang="en-US" sz="1200" dirty="0"/>
+          </a:p>
+        </p:txBody>
+      </p:sp>
+    </p:spTree>
+  </p:cSld>
+  <p:clrMapOvr>
+    <a:masterClrMapping/>
+  </p:clrMapOvr>
+</p:sld>
+</file>
+
+<file path=ppt/slides/slide8.xml><?xml version="1.0" encoding="utf-8"?>
+<p:sld xmlns:a="http://schemas.openxmlformats.org/drawingml/2006/main" xmlns:r="http://schemas.openxmlformats.org/officeDocument/2006/relationships" xmlns:p="http://schemas.openxmlformats.org/presentationml/2006/main">
+  <p:cSld name="Slide 8">
+    <p:bg>
+      <p:bgPr>
+        <a:solidFill>
           <a:srgbClr val="23201C"/>
         </a:solidFill>
       </p:bgPr>
@@ -10699,7 +11320,7 @@
                 <a:ea typeface="Calibri" pitchFamily="34" charset="-122"/>
                 <a:cs typeface="Calibri" pitchFamily="34" charset="-120"/>
               </a:rPr>
-              <a:t>EN RÉSUMÉ</a:t>
+              <a:t>CONCLUSION</a:t>
             </a:r>
             <a:endParaRPr lang="en-US" sz="1200" dirty="0"/>
           </a:p>
@@ -11128,7 +11749,7 @@
                 <a:ea typeface="Calibri" pitchFamily="34" charset="-122"/>
                 <a:cs typeface="Calibri" pitchFamily="34" charset="-120"/>
               </a:rPr>
-              <a:t>Annexes : embedding · fine-tuning · limites</a:t>
+              <a:t>Annexes : ce que l'embedding a appris · ce que le fine-tuning a changé</a:t>
             </a:r>
             <a:endParaRPr lang="en-US" sz="1100" dirty="0"/>
           </a:p>
@@ -11170,1748 +11791,6 @@
               <a:t>Marine Deldicque   ·   Jedha CDSD   ·   Bloc 4</a:t>
             </a:r>
             <a:endParaRPr lang="en-US" sz="1000" dirty="0"/>
-          </a:p>
-        </p:txBody>
-      </p:sp>
-    </p:spTree>
-  </p:cSld>
-  <p:clrMapOvr>
-    <a:masterClrMapping/>
-  </p:clrMapOvr>
-</p:sld>
-</file>
-
-<file path=ppt/slides/slide8.xml><?xml version="1.0" encoding="utf-8"?>
-<p:sld xmlns:a="http://schemas.openxmlformats.org/drawingml/2006/main" xmlns:r="http://schemas.openxmlformats.org/officeDocument/2006/relationships" xmlns:p="http://schemas.openxmlformats.org/presentationml/2006/main">
-  <p:cSld name="Slide 8">
-    <p:bg>
-      <p:bgPr>
-        <a:solidFill>
-          <a:srgbClr val="FAF7F0"/>
-        </a:solidFill>
-      </p:bgPr>
-    </p:bg>
-    <p:spTree>
-      <p:nvGrpSpPr>
-        <p:cNvPr id="1" name=""/>
-        <p:cNvGrpSpPr/>
-        <p:nvPr/>
-      </p:nvGrpSpPr>
-      <p:grpSpPr>
-        <a:xfrm>
-          <a:off x="0" y="0"/>
-          <a:ext cx="0" cy="0"/>
-          <a:chOff x="0" y="0"/>
-          <a:chExt cx="0" cy="0"/>
-        </a:xfrm>
-      </p:grpSpPr>
-      <p:sp>
-        <p:nvSpPr>
-          <p:cNvPr id="2" name="Text 0"/>
-          <p:cNvSpPr txBox="1"/>
-          <p:nvPr/>
-        </p:nvSpPr>
-        <p:spPr>
-          <a:xfrm>
-            <a:off x="777240" y="502920"/>
-            <a:ext cx="10058400" cy="274320"/>
-          </a:xfrm>
-          <a:prstGeom prst="rect">
-            <a:avLst/>
-          </a:prstGeom>
-          <a:noFill/>
-          <a:ln/>
-        </p:spPr>
-        <p:txBody>
-          <a:bodyPr wrap="square" lIns="0" tIns="0" rIns="0" bIns="0" rtlCol="0" anchor="ctr"/>
-          <a:lstStyle/>
-          <a:p>
-            <a:pPr indent="0" marL="0">
-              <a:buNone/>
-            </a:pPr>
-            <a:r>
-              <a:rPr lang="en-US" sz="1200" b="1" spc="200" kern="0" dirty="0">
-                <a:solidFill>
-                  <a:srgbClr val="B5503F"/>
-                </a:solidFill>
-                <a:latin typeface="Calibri" pitchFamily="34" charset="0"/>
-                <a:ea typeface="Calibri" pitchFamily="34" charset="-122"/>
-                <a:cs typeface="Calibri" pitchFamily="34" charset="-120"/>
-              </a:rPr>
-              <a:t>ANNEXE · LA BRIQUE CLÉ</a:t>
-            </a:r>
-            <a:endParaRPr lang="en-US" sz="1200" dirty="0"/>
-          </a:p>
-        </p:txBody>
-      </p:sp>
-      <p:sp>
-        <p:nvSpPr>
-          <p:cNvPr id="3" name="Text 1"/>
-          <p:cNvSpPr txBox="1"/>
-          <p:nvPr/>
-        </p:nvSpPr>
-        <p:spPr>
-          <a:xfrm>
-            <a:off x="777240" y="777240"/>
-            <a:ext cx="10607040" cy="731520"/>
-          </a:xfrm>
-          <a:prstGeom prst="rect">
-            <a:avLst/>
-          </a:prstGeom>
-          <a:noFill/>
-          <a:ln/>
-        </p:spPr>
-        <p:txBody>
-          <a:bodyPr wrap="square" lIns="0" tIns="0" rIns="0" bIns="0" rtlCol="0" anchor="ctr"/>
-          <a:lstStyle/>
-          <a:p>
-            <a:pPr indent="0" marL="0">
-              <a:buNone/>
-            </a:pPr>
-            <a:r>
-              <a:rPr lang="en-US" sz="3000" b="1" dirty="0">
-                <a:solidFill>
-                  <a:srgbClr val="23201C"/>
-                </a:solidFill>
-                <a:latin typeface="Cambria" pitchFamily="34" charset="0"/>
-                <a:ea typeface="Cambria" pitchFamily="34" charset="-122"/>
-                <a:cs typeface="Cambria" pitchFamily="34" charset="-120"/>
-              </a:rPr>
-              <a:t>Qu'est-ce qu'un embedding ?</a:t>
-            </a:r>
-            <a:endParaRPr lang="en-US" sz="3000" dirty="0"/>
-          </a:p>
-        </p:txBody>
-      </p:sp>
-      <p:sp>
-        <p:nvSpPr>
-          <p:cNvPr id="4" name="Text 2"/>
-          <p:cNvSpPr txBox="1"/>
-          <p:nvPr/>
-        </p:nvSpPr>
-        <p:spPr>
-          <a:xfrm>
-            <a:off x="777240" y="6400800"/>
-            <a:ext cx="7315200" cy="274320"/>
-          </a:xfrm>
-          <a:prstGeom prst="rect">
-            <a:avLst/>
-          </a:prstGeom>
-          <a:noFill/>
-          <a:ln/>
-        </p:spPr>
-        <p:txBody>
-          <a:bodyPr wrap="square" lIns="0" tIns="0" rIns="0" bIns="0" rtlCol="0" anchor="ctr"/>
-          <a:lstStyle/>
-          <a:p>
-            <a:pPr indent="0" marL="0">
-              <a:buNone/>
-            </a:pPr>
-            <a:r>
-              <a:rPr lang="en-US" sz="900" dirty="0">
-                <a:solidFill>
-                  <a:srgbClr val="8A847A"/>
-                </a:solidFill>
-                <a:latin typeface="Calibri" pitchFamily="34" charset="0"/>
-                <a:ea typeface="Calibri" pitchFamily="34" charset="-122"/>
-                <a:cs typeface="Calibri" pitchFamily="34" charset="-120"/>
-              </a:rPr>
-              <a:t>Marine Deldicque  ·  AT&amp;T Spam Detector  ·  Bloc 4</a:t>
-            </a:r>
-            <a:endParaRPr lang="en-US" sz="900" dirty="0"/>
-          </a:p>
-        </p:txBody>
-      </p:sp>
-      <p:sp>
-        <p:nvSpPr>
-          <p:cNvPr id="5" name="Text 3"/>
-          <p:cNvSpPr txBox="1"/>
-          <p:nvPr/>
-        </p:nvSpPr>
-        <p:spPr>
-          <a:xfrm>
-            <a:off x="9555480" y="6400800"/>
-            <a:ext cx="1828800" cy="274320"/>
-          </a:xfrm>
-          <a:prstGeom prst="rect">
-            <a:avLst/>
-          </a:prstGeom>
-          <a:noFill/>
-          <a:ln/>
-        </p:spPr>
-        <p:txBody>
-          <a:bodyPr wrap="square" lIns="0" tIns="0" rIns="0" bIns="0" rtlCol="0" anchor="ctr"/>
-          <a:lstStyle/>
-          <a:p>
-            <a:pPr algn="r" indent="0" marL="0">
-              <a:buNone/>
-            </a:pPr>
-            <a:r>
-              <a:rPr lang="en-US" sz="900" dirty="0">
-                <a:solidFill>
-                  <a:srgbClr val="8A847A"/>
-                </a:solidFill>
-                <a:latin typeface="Calibri" pitchFamily="34" charset="0"/>
-                <a:ea typeface="Calibri" pitchFamily="34" charset="-122"/>
-                <a:cs typeface="Calibri" pitchFamily="34" charset="-120"/>
-              </a:rPr>
-              <a:t>Annexe 1</a:t>
-            </a:r>
-            <a:endParaRPr lang="en-US" sz="900" dirty="0"/>
-          </a:p>
-        </p:txBody>
-      </p:sp>
-      <p:sp>
-        <p:nvSpPr>
-          <p:cNvPr id="6" name="Text 4"/>
-          <p:cNvSpPr txBox="1"/>
-          <p:nvPr/>
-        </p:nvSpPr>
-        <p:spPr>
-          <a:xfrm>
-            <a:off x="777240" y="1737360"/>
-            <a:ext cx="5394960" cy="1005840"/>
-          </a:xfrm>
-          <a:prstGeom prst="rect">
-            <a:avLst/>
-          </a:prstGeom>
-          <a:noFill/>
-          <a:ln/>
-        </p:spPr>
-        <p:txBody>
-          <a:bodyPr wrap="square" lIns="0" tIns="0" rIns="0" bIns="0" rtlCol="0" anchor="t"/>
-          <a:lstStyle/>
-          <a:p>
-            <a:pPr indent="0" marL="0">
-              <a:buNone/>
-            </a:pPr>
-            <a:r>
-              <a:rPr lang="en-US" sz="1400" dirty="0">
-                <a:solidFill>
-                  <a:srgbClr val="23201C"/>
-                </a:solidFill>
-                <a:latin typeface="Calibri" pitchFamily="34" charset="0"/>
-                <a:ea typeface="Calibri" pitchFamily="34" charset="-122"/>
-                <a:cs typeface="Calibri" pitchFamily="34" charset="-120"/>
-              </a:rPr>
-              <a:t>Un numéro de jeton n'a aucun sens : « free » = 45 et « win » = 302 ne sont pas « proches ». L'embedding donne à chaque mot des coordonnées dans un espace où la distance a un sens.</a:t>
-            </a:r>
-            <a:endParaRPr lang="en-US" sz="1400" dirty="0"/>
-          </a:p>
-        </p:txBody>
-      </p:sp>
-      <p:sp>
-        <p:nvSpPr>
-          <p:cNvPr id="7" name="Shape 5"/>
-          <p:cNvSpPr/>
-          <p:nvPr/>
-        </p:nvSpPr>
-        <p:spPr>
-          <a:xfrm>
-            <a:off x="777240" y="3054096"/>
-            <a:ext cx="118872" cy="118872"/>
-          </a:xfrm>
-          <a:prstGeom prst="ellipse">
-            <a:avLst/>
-          </a:prstGeom>
-          <a:solidFill>
-            <a:srgbClr val="B5503F"/>
-          </a:solidFill>
-          <a:ln w="12700">
-            <a:solidFill>
-              <a:srgbClr val="B5503F"/>
-            </a:solidFill>
-            <a:prstDash val="solid"/>
-          </a:ln>
-        </p:spPr>
-      </p:sp>
-      <p:sp>
-        <p:nvSpPr>
-          <p:cNvPr id="8" name="Text 6"/>
-          <p:cNvSpPr txBox="1"/>
-          <p:nvPr/>
-        </p:nvSpPr>
-        <p:spPr>
-          <a:xfrm>
-            <a:off x="1051560" y="2880360"/>
-            <a:ext cx="5120640" cy="457200"/>
-          </a:xfrm>
-          <a:prstGeom prst="rect">
-            <a:avLst/>
-          </a:prstGeom>
-          <a:noFill/>
-          <a:ln/>
-        </p:spPr>
-        <p:txBody>
-          <a:bodyPr wrap="square" lIns="0" tIns="0" rIns="0" bIns="0" rtlCol="0" anchor="ctr"/>
-          <a:lstStyle/>
-          <a:p>
-            <a:pPr indent="0" marL="0">
-              <a:buNone/>
-            </a:pPr>
-            <a:r>
-              <a:rPr lang="en-US" sz="1300" b="1" dirty="0">
-                <a:solidFill>
-                  <a:srgbClr val="23201C"/>
-                </a:solidFill>
-                <a:latin typeface="Calibri" pitchFamily="34" charset="0"/>
-                <a:ea typeface="Calibri" pitchFamily="34" charset="-122"/>
-                <a:cs typeface="Calibri" pitchFamily="34" charset="-120"/>
-              </a:rPr>
-              <a:t>Vecteur dense  </a:t>
-            </a:r>
-            <a:pPr indent="0" marL="0">
-              <a:buNone/>
-            </a:pPr>
-            <a:r>
-              <a:rPr lang="en-US" sz="1300" dirty="0">
-                <a:solidFill>
-                  <a:srgbClr val="8A847A"/>
-                </a:solidFill>
-                <a:latin typeface="Calibri" pitchFamily="34" charset="0"/>
-                <a:ea typeface="Calibri" pitchFamily="34" charset="-122"/>
-                <a:cs typeface="Calibri" pitchFamily="34" charset="-120"/>
-              </a:rPr>
-              <a:t>chaque mot devient 32 nombres réels (10 000 mots × 32 = la matrice d'embedding)</a:t>
-            </a:r>
-            <a:endParaRPr lang="en-US" sz="1300" dirty="0"/>
-          </a:p>
-        </p:txBody>
-      </p:sp>
-      <p:sp>
-        <p:nvSpPr>
-          <p:cNvPr id="9" name="Shape 7"/>
-          <p:cNvSpPr/>
-          <p:nvPr/>
-        </p:nvSpPr>
-        <p:spPr>
-          <a:xfrm>
-            <a:off x="777240" y="3648456"/>
-            <a:ext cx="118872" cy="118872"/>
-          </a:xfrm>
-          <a:prstGeom prst="ellipse">
-            <a:avLst/>
-          </a:prstGeom>
-          <a:solidFill>
-            <a:srgbClr val="B5503F"/>
-          </a:solidFill>
-          <a:ln w="12700">
-            <a:solidFill>
-              <a:srgbClr val="B5503F"/>
-            </a:solidFill>
-            <a:prstDash val="solid"/>
-          </a:ln>
-        </p:spPr>
-      </p:sp>
-      <p:sp>
-        <p:nvSpPr>
-          <p:cNvPr id="10" name="Text 8"/>
-          <p:cNvSpPr txBox="1"/>
-          <p:nvPr/>
-        </p:nvSpPr>
-        <p:spPr>
-          <a:xfrm>
-            <a:off x="1051560" y="3474720"/>
-            <a:ext cx="5120640" cy="457200"/>
-          </a:xfrm>
-          <a:prstGeom prst="rect">
-            <a:avLst/>
-          </a:prstGeom>
-          <a:noFill/>
-          <a:ln/>
-        </p:spPr>
-        <p:txBody>
-          <a:bodyPr wrap="square" lIns="0" tIns="0" rIns="0" bIns="0" rtlCol="0" anchor="ctr"/>
-          <a:lstStyle/>
-          <a:p>
-            <a:pPr indent="0" marL="0">
-              <a:buNone/>
-            </a:pPr>
-            <a:r>
-              <a:rPr lang="en-US" sz="1300" b="1" dirty="0">
-                <a:solidFill>
-                  <a:srgbClr val="23201C"/>
-                </a:solidFill>
-                <a:latin typeface="Calibri" pitchFamily="34" charset="0"/>
-                <a:ea typeface="Calibri" pitchFamily="34" charset="-122"/>
-                <a:cs typeface="Calibri" pitchFamily="34" charset="-120"/>
-              </a:rPr>
-              <a:t>Appris pendant l'entraînement  </a:t>
-            </a:r>
-            <a:pPr indent="0" marL="0">
-              <a:buNone/>
-            </a:pPr>
-            <a:r>
-              <a:rPr lang="en-US" sz="1300" dirty="0">
-                <a:solidFill>
-                  <a:srgbClr val="8A847A"/>
-                </a:solidFill>
-                <a:latin typeface="Calibri" pitchFamily="34" charset="0"/>
-                <a:ea typeface="Calibri" pitchFamily="34" charset="-122"/>
-                <a:cs typeface="Calibri" pitchFamily="34" charset="-120"/>
-              </a:rPr>
-              <a:t>au départ aléatoire ; l'objectif « ham ou spam » rapproche les mots qui jouent le même rôle</a:t>
-            </a:r>
-            <a:endParaRPr lang="en-US" sz="1300" dirty="0"/>
-          </a:p>
-        </p:txBody>
-      </p:sp>
-      <p:sp>
-        <p:nvSpPr>
-          <p:cNvPr id="11" name="Shape 9"/>
-          <p:cNvSpPr/>
-          <p:nvPr/>
-        </p:nvSpPr>
-        <p:spPr>
-          <a:xfrm>
-            <a:off x="777240" y="4242816"/>
-            <a:ext cx="118872" cy="118872"/>
-          </a:xfrm>
-          <a:prstGeom prst="ellipse">
-            <a:avLst/>
-          </a:prstGeom>
-          <a:solidFill>
-            <a:srgbClr val="B5503F"/>
-          </a:solidFill>
-          <a:ln w="12700">
-            <a:solidFill>
-              <a:srgbClr val="B5503F"/>
-            </a:solidFill>
-            <a:prstDash val="solid"/>
-          </a:ln>
-        </p:spPr>
-      </p:sp>
-      <p:sp>
-        <p:nvSpPr>
-          <p:cNvPr id="12" name="Text 10"/>
-          <p:cNvSpPr txBox="1"/>
-          <p:nvPr/>
-        </p:nvSpPr>
-        <p:spPr>
-          <a:xfrm>
-            <a:off x="1051560" y="4069080"/>
-            <a:ext cx="5120640" cy="457200"/>
-          </a:xfrm>
-          <a:prstGeom prst="rect">
-            <a:avLst/>
-          </a:prstGeom>
-          <a:noFill/>
-          <a:ln/>
-        </p:spPr>
-        <p:txBody>
-          <a:bodyPr wrap="square" lIns="0" tIns="0" rIns="0" bIns="0" rtlCol="0" anchor="ctr"/>
-          <a:lstStyle/>
-          <a:p>
-            <a:pPr indent="0" marL="0">
-              <a:buNone/>
-            </a:pPr>
-            <a:r>
-              <a:rPr lang="en-US" sz="1300" b="1" dirty="0">
-                <a:solidFill>
-                  <a:srgbClr val="23201C"/>
-                </a:solidFill>
-                <a:latin typeface="Calibri" pitchFamily="34" charset="0"/>
-                <a:ea typeface="Calibri" pitchFamily="34" charset="-122"/>
-                <a:cs typeface="Calibri" pitchFamily="34" charset="-120"/>
-              </a:rPr>
-              <a:t>Proximité = sens  </a:t>
-            </a:r>
-            <a:pPr indent="0" marL="0">
-              <a:buNone/>
-            </a:pPr>
-            <a:r>
-              <a:rPr lang="en-US" sz="1300" dirty="0">
-                <a:solidFill>
-                  <a:srgbClr val="8A847A"/>
-                </a:solidFill>
-                <a:latin typeface="Calibri" pitchFamily="34" charset="0"/>
-                <a:ea typeface="Calibri" pitchFamily="34" charset="-122"/>
-                <a:cs typeface="Calibri" pitchFamily="34" charset="-120"/>
-              </a:rPr>
-              <a:t>mots proches dans l'espace = rôle similaire dans la décision</a:t>
-            </a:r>
-            <a:endParaRPr lang="en-US" sz="1300" dirty="0"/>
-          </a:p>
-        </p:txBody>
-      </p:sp>
-      <p:sp>
-        <p:nvSpPr>
-          <p:cNvPr id="13" name="Shape 11"/>
-          <p:cNvSpPr/>
-          <p:nvPr/>
-        </p:nvSpPr>
-        <p:spPr>
-          <a:xfrm>
-            <a:off x="777240" y="4837176"/>
-            <a:ext cx="118872" cy="118872"/>
-          </a:xfrm>
-          <a:prstGeom prst="ellipse">
-            <a:avLst/>
-          </a:prstGeom>
-          <a:solidFill>
-            <a:srgbClr val="B5503F"/>
-          </a:solidFill>
-          <a:ln w="12700">
-            <a:solidFill>
-              <a:srgbClr val="B5503F"/>
-            </a:solidFill>
-            <a:prstDash val="solid"/>
-          </a:ln>
-        </p:spPr>
-      </p:sp>
-      <p:sp>
-        <p:nvSpPr>
-          <p:cNvPr id="14" name="Text 12"/>
-          <p:cNvSpPr txBox="1"/>
-          <p:nvPr/>
-        </p:nvSpPr>
-        <p:spPr>
-          <a:xfrm>
-            <a:off x="1051560" y="4663440"/>
-            <a:ext cx="5120640" cy="457200"/>
-          </a:xfrm>
-          <a:prstGeom prst="rect">
-            <a:avLst/>
-          </a:prstGeom>
-          <a:noFill/>
-          <a:ln/>
-        </p:spPr>
-        <p:txBody>
-          <a:bodyPr wrap="square" lIns="0" tIns="0" rIns="0" bIns="0" rtlCol="0" anchor="ctr"/>
-          <a:lstStyle/>
-          <a:p>
-            <a:pPr indent="0" marL="0">
-              <a:buNone/>
-            </a:pPr>
-            <a:r>
-              <a:rPr lang="en-US" sz="1300" b="1" dirty="0">
-                <a:solidFill>
-                  <a:srgbClr val="23201C"/>
-                </a:solidFill>
-                <a:latin typeface="Calibri" pitchFamily="34" charset="0"/>
-                <a:ea typeface="Calibri" pitchFamily="34" charset="-122"/>
-                <a:cs typeface="Calibri" pitchFamily="34" charset="-120"/>
-              </a:rPr>
-              <a:t>Dans DistilBERT  </a:t>
-            </a:r>
-            <a:pPr indent="0" marL="0">
-              <a:buNone/>
-            </a:pPr>
-            <a:r>
-              <a:rPr lang="en-US" sz="1300" dirty="0">
-                <a:solidFill>
-                  <a:srgbClr val="8A847A"/>
-                </a:solidFill>
-                <a:latin typeface="Calibri" pitchFamily="34" charset="0"/>
-                <a:ea typeface="Calibri" pitchFamily="34" charset="-122"/>
-                <a:cs typeface="Calibri" pitchFamily="34" charset="-120"/>
-              </a:rPr>
-              <a:t>embeddings contextuels : le vecteur de « free » change selon la phrase (attention)</a:t>
-            </a:r>
-            <a:endParaRPr lang="en-US" sz="1300" dirty="0"/>
-          </a:p>
-        </p:txBody>
-      </p:sp>
-      <p:sp>
-        <p:nvSpPr>
-          <p:cNvPr id="15" name="Text 13"/>
-          <p:cNvSpPr txBox="1"/>
-          <p:nvPr/>
-        </p:nvSpPr>
-        <p:spPr>
-          <a:xfrm>
-            <a:off x="777240" y="5349240"/>
-            <a:ext cx="5394960" cy="640080"/>
-          </a:xfrm>
-          <a:prstGeom prst="rect">
-            <a:avLst/>
-          </a:prstGeom>
-          <a:noFill/>
-          <a:ln/>
-        </p:spPr>
-        <p:txBody>
-          <a:bodyPr wrap="square" lIns="0" tIns="0" rIns="0" bIns="0" rtlCol="0" anchor="t"/>
-          <a:lstStyle/>
-          <a:p>
-            <a:pPr indent="0" marL="0">
-              <a:buNone/>
-            </a:pPr>
-            <a:r>
-              <a:rPr lang="en-US" sz="1100" i="1" dirty="0">
-                <a:solidFill>
-                  <a:srgbClr val="8A847A"/>
-                </a:solidFill>
-                <a:latin typeface="Calibri" pitchFamily="34" charset="0"/>
-                <a:ea typeface="Calibri" pitchFamily="34" charset="-122"/>
-                <a:cs typeface="Calibri" pitchFamily="34" charset="-120"/>
-              </a:rPr>
-              <a:t>Vérifié dans le notebook (plus proches voisins, cosinus) : « prize » est proche de urgent, txt, mobile, stop ; « ok » de going, said, sorry, still. Le jeton « £ » (montants) ressort aussi côté spam.</a:t>
-            </a:r>
-            <a:endParaRPr lang="en-US" sz="1100" dirty="0"/>
-          </a:p>
-        </p:txBody>
-      </p:sp>
-      <p:sp>
-        <p:nvSpPr>
-          <p:cNvPr id="16" name="Shape 14"/>
-          <p:cNvSpPr/>
-          <p:nvPr/>
-        </p:nvSpPr>
-        <p:spPr>
-          <a:xfrm>
-            <a:off x="6766560" y="1691640"/>
-            <a:ext cx="4617720" cy="4297680"/>
-          </a:xfrm>
-          <a:prstGeom prst="roundRect">
-            <a:avLst>
-              <a:gd name="adj" fmla="val 2553"/>
-            </a:avLst>
-          </a:prstGeom>
-          <a:solidFill>
-            <a:srgbClr val="FFFFFF"/>
-          </a:solidFill>
-          <a:ln w="12700">
-            <a:solidFill>
-              <a:srgbClr val="E4DDD0"/>
-            </a:solidFill>
-            <a:prstDash val="solid"/>
-          </a:ln>
-          <a:effectLst>
-            <a:outerShdw sx="100000" sy="100000" kx="0" ky="0" algn="bl" rotWithShape="0" blurRad="88900" dist="25400" dir="5400000">
-              <a:srgbClr val="000000">
-                <a:alpha val="10000"/>
-              </a:srgbClr>
-            </a:outerShdw>
-          </a:effectLst>
-        </p:spPr>
-      </p:sp>
-      <p:sp>
-        <p:nvSpPr>
-          <p:cNvPr id="17" name="Text 15"/>
-          <p:cNvSpPr txBox="1"/>
-          <p:nvPr/>
-        </p:nvSpPr>
-        <p:spPr>
-          <a:xfrm>
-            <a:off x="7086600" y="1920240"/>
-            <a:ext cx="4023360" cy="365760"/>
-          </a:xfrm>
-          <a:prstGeom prst="rect">
-            <a:avLst/>
-          </a:prstGeom>
-          <a:noFill/>
-          <a:ln/>
-        </p:spPr>
-        <p:txBody>
-          <a:bodyPr wrap="square" lIns="0" tIns="0" rIns="0" bIns="0" rtlCol="0" anchor="ctr"/>
-          <a:lstStyle/>
-          <a:p>
-            <a:pPr indent="0" marL="0">
-              <a:buNone/>
-            </a:pPr>
-            <a:r>
-              <a:rPr lang="en-US" sz="1300" b="1" dirty="0">
-                <a:solidFill>
-                  <a:srgbClr val="8A847A"/>
-                </a:solidFill>
-                <a:latin typeface="Calibri" pitchFamily="34" charset="0"/>
-                <a:ea typeface="Calibri" pitchFamily="34" charset="-122"/>
-                <a:cs typeface="Calibri" pitchFamily="34" charset="-120"/>
-              </a:rPr>
-              <a:t>L'espace appris par le modèle 1 (projection 2D)</a:t>
-            </a:r>
-            <a:endParaRPr lang="en-US" sz="1300" dirty="0"/>
-          </a:p>
-        </p:txBody>
-      </p:sp>
-      <p:sp>
-        <p:nvSpPr>
-          <p:cNvPr id="18" name="Shape 16"/>
-          <p:cNvSpPr/>
-          <p:nvPr/>
-        </p:nvSpPr>
-        <p:spPr>
-          <a:xfrm>
-            <a:off x="7040880" y="2468880"/>
-            <a:ext cx="2103120" cy="2377440"/>
-          </a:xfrm>
-          <a:prstGeom prst="ellipse">
-            <a:avLst/>
-          </a:prstGeom>
-          <a:solidFill>
-            <a:srgbClr val="F6E4E0"/>
-          </a:solidFill>
-          <a:ln w="12700">
-            <a:solidFill>
-              <a:srgbClr val="F6E4E0"/>
-            </a:solidFill>
-            <a:prstDash val="solid"/>
-          </a:ln>
-        </p:spPr>
-      </p:sp>
-      <p:sp>
-        <p:nvSpPr>
-          <p:cNvPr id="19" name="Shape 17"/>
-          <p:cNvSpPr/>
-          <p:nvPr/>
-        </p:nvSpPr>
-        <p:spPr>
-          <a:xfrm>
-            <a:off x="9144000" y="3108960"/>
-            <a:ext cx="2103120" cy="2377440"/>
-          </a:xfrm>
-          <a:prstGeom prst="ellipse">
-            <a:avLst/>
-          </a:prstGeom>
-          <a:solidFill>
-            <a:srgbClr val="E4EBE0"/>
-          </a:solidFill>
-          <a:ln w="12700">
-            <a:solidFill>
-              <a:srgbClr val="E4EBE0"/>
-            </a:solidFill>
-            <a:prstDash val="solid"/>
-          </a:ln>
-        </p:spPr>
-      </p:sp>
-      <p:sp>
-        <p:nvSpPr>
-          <p:cNvPr id="20" name="Shape 18"/>
-          <p:cNvSpPr/>
-          <p:nvPr/>
-        </p:nvSpPr>
-        <p:spPr>
-          <a:xfrm>
-            <a:off x="7269480" y="2743200"/>
-            <a:ext cx="685800" cy="329184"/>
-          </a:xfrm>
-          <a:prstGeom prst="roundRect">
-            <a:avLst>
-              <a:gd name="adj" fmla="val 50000"/>
-            </a:avLst>
-          </a:prstGeom>
-          <a:solidFill>
-            <a:srgbClr val="B5503F"/>
-          </a:solidFill>
-          <a:ln w="12700">
-            <a:solidFill>
-              <a:srgbClr val="B5503F"/>
-            </a:solidFill>
-            <a:prstDash val="solid"/>
-          </a:ln>
-        </p:spPr>
-      </p:sp>
-      <p:sp>
-        <p:nvSpPr>
-          <p:cNvPr id="21" name="Text 19"/>
-          <p:cNvSpPr txBox="1"/>
-          <p:nvPr/>
-        </p:nvSpPr>
-        <p:spPr>
-          <a:xfrm>
-            <a:off x="7269480" y="2743200"/>
-            <a:ext cx="685800" cy="329184"/>
-          </a:xfrm>
-          <a:prstGeom prst="rect">
-            <a:avLst/>
-          </a:prstGeom>
-          <a:noFill/>
-          <a:ln/>
-        </p:spPr>
-        <p:txBody>
-          <a:bodyPr wrap="square" lIns="0" tIns="0" rIns="0" bIns="0" rtlCol="0" anchor="ctr"/>
-          <a:lstStyle/>
-          <a:p>
-            <a:pPr algn="ctr" indent="0" marL="0">
-              <a:buNone/>
-            </a:pPr>
-            <a:r>
-              <a:rPr lang="en-US" sz="1150" b="1" dirty="0">
-                <a:solidFill>
-                  <a:srgbClr val="FFFFFF"/>
-                </a:solidFill>
-                <a:latin typeface="Calibri" pitchFamily="34" charset="0"/>
-                <a:ea typeface="Calibri" pitchFamily="34" charset="-122"/>
-                <a:cs typeface="Calibri" pitchFamily="34" charset="-120"/>
-              </a:rPr>
-              <a:t>free</a:t>
-            </a:r>
-            <a:endParaRPr lang="en-US" sz="1150" dirty="0"/>
-          </a:p>
-        </p:txBody>
-      </p:sp>
-      <p:sp>
-        <p:nvSpPr>
-          <p:cNvPr id="22" name="Shape 20"/>
-          <p:cNvSpPr/>
-          <p:nvPr/>
-        </p:nvSpPr>
-        <p:spPr>
-          <a:xfrm>
-            <a:off x="8092440" y="2606040"/>
-            <a:ext cx="594360" cy="329184"/>
-          </a:xfrm>
-          <a:prstGeom prst="roundRect">
-            <a:avLst>
-              <a:gd name="adj" fmla="val 50000"/>
-            </a:avLst>
-          </a:prstGeom>
-          <a:solidFill>
-            <a:srgbClr val="B5503F"/>
-          </a:solidFill>
-          <a:ln w="12700">
-            <a:solidFill>
-              <a:srgbClr val="B5503F"/>
-            </a:solidFill>
-            <a:prstDash val="solid"/>
-          </a:ln>
-        </p:spPr>
-      </p:sp>
-      <p:sp>
-        <p:nvSpPr>
-          <p:cNvPr id="23" name="Text 21"/>
-          <p:cNvSpPr txBox="1"/>
-          <p:nvPr/>
-        </p:nvSpPr>
-        <p:spPr>
-          <a:xfrm>
-            <a:off x="8092440" y="2606040"/>
-            <a:ext cx="594360" cy="329184"/>
-          </a:xfrm>
-          <a:prstGeom prst="rect">
-            <a:avLst/>
-          </a:prstGeom>
-          <a:noFill/>
-          <a:ln/>
-        </p:spPr>
-        <p:txBody>
-          <a:bodyPr wrap="square" lIns="0" tIns="0" rIns="0" bIns="0" rtlCol="0" anchor="ctr"/>
-          <a:lstStyle/>
-          <a:p>
-            <a:pPr algn="ctr" indent="0" marL="0">
-              <a:buNone/>
-            </a:pPr>
-            <a:r>
-              <a:rPr lang="en-US" sz="1150" b="1" dirty="0">
-                <a:solidFill>
-                  <a:srgbClr val="FFFFFF"/>
-                </a:solidFill>
-                <a:latin typeface="Calibri" pitchFamily="34" charset="0"/>
-                <a:ea typeface="Calibri" pitchFamily="34" charset="-122"/>
-                <a:cs typeface="Calibri" pitchFamily="34" charset="-120"/>
-              </a:rPr>
-              <a:t>win</a:t>
-            </a:r>
-            <a:endParaRPr lang="en-US" sz="1150" dirty="0"/>
-          </a:p>
-        </p:txBody>
-      </p:sp>
-      <p:sp>
-        <p:nvSpPr>
-          <p:cNvPr id="24" name="Shape 22"/>
-          <p:cNvSpPr/>
-          <p:nvPr/>
-        </p:nvSpPr>
-        <p:spPr>
-          <a:xfrm>
-            <a:off x="7406640" y="3246120"/>
-            <a:ext cx="731520" cy="329184"/>
-          </a:xfrm>
-          <a:prstGeom prst="roundRect">
-            <a:avLst>
-              <a:gd name="adj" fmla="val 50000"/>
-            </a:avLst>
-          </a:prstGeom>
-          <a:solidFill>
-            <a:srgbClr val="B5503F"/>
-          </a:solidFill>
-          <a:ln w="12700">
-            <a:solidFill>
-              <a:srgbClr val="B5503F"/>
-            </a:solidFill>
-            <a:prstDash val="solid"/>
-          </a:ln>
-        </p:spPr>
-      </p:sp>
-      <p:sp>
-        <p:nvSpPr>
-          <p:cNvPr id="25" name="Text 23"/>
-          <p:cNvSpPr txBox="1"/>
-          <p:nvPr/>
-        </p:nvSpPr>
-        <p:spPr>
-          <a:xfrm>
-            <a:off x="7406640" y="3246120"/>
-            <a:ext cx="731520" cy="329184"/>
-          </a:xfrm>
-          <a:prstGeom prst="rect">
-            <a:avLst/>
-          </a:prstGeom>
-          <a:noFill/>
-          <a:ln/>
-        </p:spPr>
-        <p:txBody>
-          <a:bodyPr wrap="square" lIns="0" tIns="0" rIns="0" bIns="0" rtlCol="0" anchor="ctr"/>
-          <a:lstStyle/>
-          <a:p>
-            <a:pPr algn="ctr" indent="0" marL="0">
-              <a:buNone/>
-            </a:pPr>
-            <a:r>
-              <a:rPr lang="en-US" sz="1150" b="1" dirty="0">
-                <a:solidFill>
-                  <a:srgbClr val="FFFFFF"/>
-                </a:solidFill>
-                <a:latin typeface="Calibri" pitchFamily="34" charset="0"/>
-                <a:ea typeface="Calibri" pitchFamily="34" charset="-122"/>
-                <a:cs typeface="Calibri" pitchFamily="34" charset="-120"/>
-              </a:rPr>
-              <a:t>prize</a:t>
-            </a:r>
-            <a:endParaRPr lang="en-US" sz="1150" dirty="0"/>
-          </a:p>
-        </p:txBody>
-      </p:sp>
-      <p:sp>
-        <p:nvSpPr>
-          <p:cNvPr id="26" name="Shape 24"/>
-          <p:cNvSpPr/>
-          <p:nvPr/>
-        </p:nvSpPr>
-        <p:spPr>
-          <a:xfrm>
-            <a:off x="8183880" y="3200400"/>
-            <a:ext cx="731520" cy="329184"/>
-          </a:xfrm>
-          <a:prstGeom prst="roundRect">
-            <a:avLst>
-              <a:gd name="adj" fmla="val 50000"/>
-            </a:avLst>
-          </a:prstGeom>
-          <a:solidFill>
-            <a:srgbClr val="B5503F"/>
-          </a:solidFill>
-          <a:ln w="12700">
-            <a:solidFill>
-              <a:srgbClr val="B5503F"/>
-            </a:solidFill>
-            <a:prstDash val="solid"/>
-          </a:ln>
-        </p:spPr>
-      </p:sp>
-      <p:sp>
-        <p:nvSpPr>
-          <p:cNvPr id="27" name="Text 25"/>
-          <p:cNvSpPr txBox="1"/>
-          <p:nvPr/>
-        </p:nvSpPr>
-        <p:spPr>
-          <a:xfrm>
-            <a:off x="8183880" y="3200400"/>
-            <a:ext cx="731520" cy="329184"/>
-          </a:xfrm>
-          <a:prstGeom prst="rect">
-            <a:avLst/>
-          </a:prstGeom>
-          <a:noFill/>
-          <a:ln/>
-        </p:spPr>
-        <p:txBody>
-          <a:bodyPr wrap="square" lIns="0" tIns="0" rIns="0" bIns="0" rtlCol="0" anchor="ctr"/>
-          <a:lstStyle/>
-          <a:p>
-            <a:pPr algn="ctr" indent="0" marL="0">
-              <a:buNone/>
-            </a:pPr>
-            <a:r>
-              <a:rPr lang="en-US" sz="1150" b="1" dirty="0">
-                <a:solidFill>
-                  <a:srgbClr val="FFFFFF"/>
-                </a:solidFill>
-                <a:latin typeface="Calibri" pitchFamily="34" charset="0"/>
-                <a:ea typeface="Calibri" pitchFamily="34" charset="-122"/>
-                <a:cs typeface="Calibri" pitchFamily="34" charset="-120"/>
-              </a:rPr>
-              <a:t>claim</a:t>
-            </a:r>
-            <a:endParaRPr lang="en-US" sz="1150" dirty="0"/>
-          </a:p>
-        </p:txBody>
-      </p:sp>
-      <p:sp>
-        <p:nvSpPr>
-          <p:cNvPr id="28" name="Shape 26"/>
-          <p:cNvSpPr/>
-          <p:nvPr/>
-        </p:nvSpPr>
-        <p:spPr>
-          <a:xfrm>
-            <a:off x="7315200" y="3794760"/>
-            <a:ext cx="594360" cy="329184"/>
-          </a:xfrm>
-          <a:prstGeom prst="roundRect">
-            <a:avLst>
-              <a:gd name="adj" fmla="val 50000"/>
-            </a:avLst>
-          </a:prstGeom>
-          <a:solidFill>
-            <a:srgbClr val="B5503F"/>
-          </a:solidFill>
-          <a:ln w="12700">
-            <a:solidFill>
-              <a:srgbClr val="B5503F"/>
-            </a:solidFill>
-            <a:prstDash val="solid"/>
-          </a:ln>
-        </p:spPr>
-      </p:sp>
-      <p:sp>
-        <p:nvSpPr>
-          <p:cNvPr id="29" name="Text 27"/>
-          <p:cNvSpPr txBox="1"/>
-          <p:nvPr/>
-        </p:nvSpPr>
-        <p:spPr>
-          <a:xfrm>
-            <a:off x="7315200" y="3794760"/>
-            <a:ext cx="594360" cy="329184"/>
-          </a:xfrm>
-          <a:prstGeom prst="rect">
-            <a:avLst/>
-          </a:prstGeom>
-          <a:noFill/>
-          <a:ln/>
-        </p:spPr>
-        <p:txBody>
-          <a:bodyPr wrap="square" lIns="0" tIns="0" rIns="0" bIns="0" rtlCol="0" anchor="ctr"/>
-          <a:lstStyle/>
-          <a:p>
-            <a:pPr algn="ctr" indent="0" marL="0">
-              <a:buNone/>
-            </a:pPr>
-            <a:r>
-              <a:rPr lang="en-US" sz="1150" b="1" dirty="0">
-                <a:solidFill>
-                  <a:srgbClr val="FFFFFF"/>
-                </a:solidFill>
-                <a:latin typeface="Calibri" pitchFamily="34" charset="0"/>
-                <a:ea typeface="Calibri" pitchFamily="34" charset="-122"/>
-                <a:cs typeface="Calibri" pitchFamily="34" charset="-120"/>
-              </a:rPr>
-              <a:t>txt</a:t>
-            </a:r>
-            <a:endParaRPr lang="en-US" sz="1150" dirty="0"/>
-          </a:p>
-        </p:txBody>
-      </p:sp>
-      <p:sp>
-        <p:nvSpPr>
-          <p:cNvPr id="30" name="Shape 28"/>
-          <p:cNvSpPr/>
-          <p:nvPr/>
-        </p:nvSpPr>
-        <p:spPr>
-          <a:xfrm>
-            <a:off x="8001000" y="3840480"/>
-            <a:ext cx="868680" cy="329184"/>
-          </a:xfrm>
-          <a:prstGeom prst="roundRect">
-            <a:avLst>
-              <a:gd name="adj" fmla="val 50000"/>
-            </a:avLst>
-          </a:prstGeom>
-          <a:solidFill>
-            <a:srgbClr val="B5503F"/>
-          </a:solidFill>
-          <a:ln w="12700">
-            <a:solidFill>
-              <a:srgbClr val="B5503F"/>
-            </a:solidFill>
-            <a:prstDash val="solid"/>
-          </a:ln>
-        </p:spPr>
-      </p:sp>
-      <p:sp>
-        <p:nvSpPr>
-          <p:cNvPr id="31" name="Text 29"/>
-          <p:cNvSpPr txBox="1"/>
-          <p:nvPr/>
-        </p:nvSpPr>
-        <p:spPr>
-          <a:xfrm>
-            <a:off x="8001000" y="3840480"/>
-            <a:ext cx="868680" cy="329184"/>
-          </a:xfrm>
-          <a:prstGeom prst="rect">
-            <a:avLst/>
-          </a:prstGeom>
-          <a:noFill/>
-          <a:ln/>
-        </p:spPr>
-        <p:txBody>
-          <a:bodyPr wrap="square" lIns="0" tIns="0" rIns="0" bIns="0" rtlCol="0" anchor="ctr"/>
-          <a:lstStyle/>
-          <a:p>
-            <a:pPr algn="ctr" indent="0" marL="0">
-              <a:buNone/>
-            </a:pPr>
-            <a:r>
-              <a:rPr lang="en-US" sz="1150" b="1" dirty="0">
-                <a:solidFill>
-                  <a:srgbClr val="FFFFFF"/>
-                </a:solidFill>
-                <a:latin typeface="Calibri" pitchFamily="34" charset="0"/>
-                <a:ea typeface="Calibri" pitchFamily="34" charset="-122"/>
-                <a:cs typeface="Calibri" pitchFamily="34" charset="-120"/>
-              </a:rPr>
-              <a:t>urgent</a:t>
-            </a:r>
-            <a:endParaRPr lang="en-US" sz="1150" dirty="0"/>
-          </a:p>
-        </p:txBody>
-      </p:sp>
-      <p:sp>
-        <p:nvSpPr>
-          <p:cNvPr id="32" name="Shape 30"/>
-          <p:cNvSpPr/>
-          <p:nvPr/>
-        </p:nvSpPr>
-        <p:spPr>
-          <a:xfrm>
-            <a:off x="7543800" y="4343400"/>
-            <a:ext cx="822960" cy="329184"/>
-          </a:xfrm>
-          <a:prstGeom prst="roundRect">
-            <a:avLst>
-              <a:gd name="adj" fmla="val 50000"/>
-            </a:avLst>
-          </a:prstGeom>
-          <a:solidFill>
-            <a:srgbClr val="B5503F"/>
-          </a:solidFill>
-          <a:ln w="12700">
-            <a:solidFill>
-              <a:srgbClr val="B5503F"/>
-            </a:solidFill>
-            <a:prstDash val="solid"/>
-          </a:ln>
-        </p:spPr>
-      </p:sp>
-      <p:sp>
-        <p:nvSpPr>
-          <p:cNvPr id="33" name="Text 31"/>
-          <p:cNvSpPr txBox="1"/>
-          <p:nvPr/>
-        </p:nvSpPr>
-        <p:spPr>
-          <a:xfrm>
-            <a:off x="7543800" y="4343400"/>
-            <a:ext cx="822960" cy="329184"/>
-          </a:xfrm>
-          <a:prstGeom prst="rect">
-            <a:avLst/>
-          </a:prstGeom>
-          <a:noFill/>
-          <a:ln/>
-        </p:spPr>
-        <p:txBody>
-          <a:bodyPr wrap="square" lIns="0" tIns="0" rIns="0" bIns="0" rtlCol="0" anchor="ctr"/>
-          <a:lstStyle/>
-          <a:p>
-            <a:pPr algn="ctr" indent="0" marL="0">
-              <a:buNone/>
-            </a:pPr>
-            <a:r>
-              <a:rPr lang="en-US" sz="1150" b="1" dirty="0">
-                <a:solidFill>
-                  <a:srgbClr val="FFFFFF"/>
-                </a:solidFill>
-                <a:latin typeface="Calibri" pitchFamily="34" charset="0"/>
-                <a:ea typeface="Calibri" pitchFamily="34" charset="-122"/>
-                <a:cs typeface="Calibri" pitchFamily="34" charset="-120"/>
-              </a:rPr>
-              <a:t>mobile</a:t>
-            </a:r>
-            <a:endParaRPr lang="en-US" sz="1150" dirty="0"/>
-          </a:p>
-        </p:txBody>
-      </p:sp>
-      <p:sp>
-        <p:nvSpPr>
-          <p:cNvPr id="34" name="Shape 32"/>
-          <p:cNvSpPr/>
-          <p:nvPr/>
-        </p:nvSpPr>
-        <p:spPr>
-          <a:xfrm>
-            <a:off x="9372600" y="3429000"/>
-            <a:ext cx="548640" cy="329184"/>
-          </a:xfrm>
-          <a:prstGeom prst="roundRect">
-            <a:avLst>
-              <a:gd name="adj" fmla="val 50000"/>
-            </a:avLst>
-          </a:prstGeom>
-          <a:solidFill>
-            <a:srgbClr val="5E7A5A"/>
-          </a:solidFill>
-          <a:ln w="12700">
-            <a:solidFill>
-              <a:srgbClr val="5E7A5A"/>
-            </a:solidFill>
-            <a:prstDash val="solid"/>
-          </a:ln>
-        </p:spPr>
-      </p:sp>
-      <p:sp>
-        <p:nvSpPr>
-          <p:cNvPr id="35" name="Text 33"/>
-          <p:cNvSpPr txBox="1"/>
-          <p:nvPr/>
-        </p:nvSpPr>
-        <p:spPr>
-          <a:xfrm>
-            <a:off x="9372600" y="3429000"/>
-            <a:ext cx="548640" cy="329184"/>
-          </a:xfrm>
-          <a:prstGeom prst="rect">
-            <a:avLst/>
-          </a:prstGeom>
-          <a:noFill/>
-          <a:ln/>
-        </p:spPr>
-        <p:txBody>
-          <a:bodyPr wrap="square" lIns="0" tIns="0" rIns="0" bIns="0" rtlCol="0" anchor="ctr"/>
-          <a:lstStyle/>
-          <a:p>
-            <a:pPr algn="ctr" indent="0" marL="0">
-              <a:buNone/>
-            </a:pPr>
-            <a:r>
-              <a:rPr lang="en-US" sz="1150" b="1" dirty="0">
-                <a:solidFill>
-                  <a:srgbClr val="FFFFFF"/>
-                </a:solidFill>
-                <a:latin typeface="Calibri" pitchFamily="34" charset="0"/>
-                <a:ea typeface="Calibri" pitchFamily="34" charset="-122"/>
-                <a:cs typeface="Calibri" pitchFamily="34" charset="-120"/>
-              </a:rPr>
-              <a:t>ok</a:t>
-            </a:r>
-            <a:endParaRPr lang="en-US" sz="1150" dirty="0"/>
-          </a:p>
-        </p:txBody>
-      </p:sp>
-      <p:sp>
-        <p:nvSpPr>
-          <p:cNvPr id="36" name="Shape 34"/>
-          <p:cNvSpPr/>
-          <p:nvPr/>
-        </p:nvSpPr>
-        <p:spPr>
-          <a:xfrm>
-            <a:off x="10058400" y="3291840"/>
-            <a:ext cx="731520" cy="329184"/>
-          </a:xfrm>
-          <a:prstGeom prst="roundRect">
-            <a:avLst>
-              <a:gd name="adj" fmla="val 50000"/>
-            </a:avLst>
-          </a:prstGeom>
-          <a:solidFill>
-            <a:srgbClr val="5E7A5A"/>
-          </a:solidFill>
-          <a:ln w="12700">
-            <a:solidFill>
-              <a:srgbClr val="5E7A5A"/>
-            </a:solidFill>
-            <a:prstDash val="solid"/>
-          </a:ln>
-        </p:spPr>
-      </p:sp>
-      <p:sp>
-        <p:nvSpPr>
-          <p:cNvPr id="37" name="Text 35"/>
-          <p:cNvSpPr txBox="1"/>
-          <p:nvPr/>
-        </p:nvSpPr>
-        <p:spPr>
-          <a:xfrm>
-            <a:off x="10058400" y="3291840"/>
-            <a:ext cx="731520" cy="329184"/>
-          </a:xfrm>
-          <a:prstGeom prst="rect">
-            <a:avLst/>
-          </a:prstGeom>
-          <a:noFill/>
-          <a:ln/>
-        </p:spPr>
-        <p:txBody>
-          <a:bodyPr wrap="square" lIns="0" tIns="0" rIns="0" bIns="0" rtlCol="0" anchor="ctr"/>
-          <a:lstStyle/>
-          <a:p>
-            <a:pPr algn="ctr" indent="0" marL="0">
-              <a:buNone/>
-            </a:pPr>
-            <a:r>
-              <a:rPr lang="en-US" sz="1150" b="1" dirty="0">
-                <a:solidFill>
-                  <a:srgbClr val="FFFFFF"/>
-                </a:solidFill>
-                <a:latin typeface="Calibri" pitchFamily="34" charset="0"/>
-                <a:ea typeface="Calibri" pitchFamily="34" charset="-122"/>
-                <a:cs typeface="Calibri" pitchFamily="34" charset="-120"/>
-              </a:rPr>
-              <a:t>going</a:t>
-            </a:r>
-            <a:endParaRPr lang="en-US" sz="1150" dirty="0"/>
-          </a:p>
-        </p:txBody>
-      </p:sp>
-      <p:sp>
-        <p:nvSpPr>
-          <p:cNvPr id="38" name="Shape 36"/>
-          <p:cNvSpPr/>
-          <p:nvPr/>
-        </p:nvSpPr>
-        <p:spPr>
-          <a:xfrm>
-            <a:off x="9418320" y="3931920"/>
-            <a:ext cx="731520" cy="329184"/>
-          </a:xfrm>
-          <a:prstGeom prst="roundRect">
-            <a:avLst>
-              <a:gd name="adj" fmla="val 50000"/>
-            </a:avLst>
-          </a:prstGeom>
-          <a:solidFill>
-            <a:srgbClr val="5E7A5A"/>
-          </a:solidFill>
-          <a:ln w="12700">
-            <a:solidFill>
-              <a:srgbClr val="5E7A5A"/>
-            </a:solidFill>
-            <a:prstDash val="solid"/>
-          </a:ln>
-        </p:spPr>
-      </p:sp>
-      <p:sp>
-        <p:nvSpPr>
-          <p:cNvPr id="39" name="Text 37"/>
-          <p:cNvSpPr txBox="1"/>
-          <p:nvPr/>
-        </p:nvSpPr>
-        <p:spPr>
-          <a:xfrm>
-            <a:off x="9418320" y="3931920"/>
-            <a:ext cx="731520" cy="329184"/>
-          </a:xfrm>
-          <a:prstGeom prst="rect">
-            <a:avLst/>
-          </a:prstGeom>
-          <a:noFill/>
-          <a:ln/>
-        </p:spPr>
-        <p:txBody>
-          <a:bodyPr wrap="square" lIns="0" tIns="0" rIns="0" bIns="0" rtlCol="0" anchor="ctr"/>
-          <a:lstStyle/>
-          <a:p>
-            <a:pPr algn="ctr" indent="0" marL="0">
-              <a:buNone/>
-            </a:pPr>
-            <a:r>
-              <a:rPr lang="en-US" sz="1150" b="1" dirty="0">
-                <a:solidFill>
-                  <a:srgbClr val="FFFFFF"/>
-                </a:solidFill>
-                <a:latin typeface="Calibri" pitchFamily="34" charset="0"/>
-                <a:ea typeface="Calibri" pitchFamily="34" charset="-122"/>
-                <a:cs typeface="Calibri" pitchFamily="34" charset="-120"/>
-              </a:rPr>
-              <a:t>home</a:t>
-            </a:r>
-            <a:endParaRPr lang="en-US" sz="1150" dirty="0"/>
-          </a:p>
-        </p:txBody>
-      </p:sp>
-      <p:sp>
-        <p:nvSpPr>
-          <p:cNvPr id="40" name="Shape 38"/>
-          <p:cNvSpPr/>
-          <p:nvPr/>
-        </p:nvSpPr>
-        <p:spPr>
-          <a:xfrm>
-            <a:off x="10195560" y="3886200"/>
-            <a:ext cx="731520" cy="329184"/>
-          </a:xfrm>
-          <a:prstGeom prst="roundRect">
-            <a:avLst>
-              <a:gd name="adj" fmla="val 50000"/>
-            </a:avLst>
-          </a:prstGeom>
-          <a:solidFill>
-            <a:srgbClr val="5E7A5A"/>
-          </a:solidFill>
-          <a:ln w="12700">
-            <a:solidFill>
-              <a:srgbClr val="5E7A5A"/>
-            </a:solidFill>
-            <a:prstDash val="solid"/>
-          </a:ln>
-        </p:spPr>
-      </p:sp>
-      <p:sp>
-        <p:nvSpPr>
-          <p:cNvPr id="41" name="Text 39"/>
-          <p:cNvSpPr txBox="1"/>
-          <p:nvPr/>
-        </p:nvSpPr>
-        <p:spPr>
-          <a:xfrm>
-            <a:off x="10195560" y="3886200"/>
-            <a:ext cx="731520" cy="329184"/>
-          </a:xfrm>
-          <a:prstGeom prst="rect">
-            <a:avLst/>
-          </a:prstGeom>
-          <a:noFill/>
-          <a:ln/>
-        </p:spPr>
-        <p:txBody>
-          <a:bodyPr wrap="square" lIns="0" tIns="0" rIns="0" bIns="0" rtlCol="0" anchor="ctr"/>
-          <a:lstStyle/>
-          <a:p>
-            <a:pPr algn="ctr" indent="0" marL="0">
-              <a:buNone/>
-            </a:pPr>
-            <a:r>
-              <a:rPr lang="en-US" sz="1150" b="1" dirty="0">
-                <a:solidFill>
-                  <a:srgbClr val="FFFFFF"/>
-                </a:solidFill>
-                <a:latin typeface="Calibri" pitchFamily="34" charset="0"/>
-                <a:ea typeface="Calibri" pitchFamily="34" charset="-122"/>
-                <a:cs typeface="Calibri" pitchFamily="34" charset="-120"/>
-              </a:rPr>
-              <a:t>sorry</a:t>
-            </a:r>
-            <a:endParaRPr lang="en-US" sz="1150" dirty="0"/>
-          </a:p>
-        </p:txBody>
-      </p:sp>
-      <p:sp>
-        <p:nvSpPr>
-          <p:cNvPr id="42" name="Shape 40"/>
-          <p:cNvSpPr/>
-          <p:nvPr/>
-        </p:nvSpPr>
-        <p:spPr>
-          <a:xfrm>
-            <a:off x="9555480" y="4480560"/>
-            <a:ext cx="640080" cy="329184"/>
-          </a:xfrm>
-          <a:prstGeom prst="roundRect">
-            <a:avLst>
-              <a:gd name="adj" fmla="val 50000"/>
-            </a:avLst>
-          </a:prstGeom>
-          <a:solidFill>
-            <a:srgbClr val="5E7A5A"/>
-          </a:solidFill>
-          <a:ln w="12700">
-            <a:solidFill>
-              <a:srgbClr val="5E7A5A"/>
-            </a:solidFill>
-            <a:prstDash val="solid"/>
-          </a:ln>
-        </p:spPr>
-      </p:sp>
-      <p:sp>
-        <p:nvSpPr>
-          <p:cNvPr id="43" name="Text 41"/>
-          <p:cNvSpPr txBox="1"/>
-          <p:nvPr/>
-        </p:nvSpPr>
-        <p:spPr>
-          <a:xfrm>
-            <a:off x="9555480" y="4480560"/>
-            <a:ext cx="640080" cy="329184"/>
-          </a:xfrm>
-          <a:prstGeom prst="rect">
-            <a:avLst/>
-          </a:prstGeom>
-          <a:noFill/>
-          <a:ln/>
-        </p:spPr>
-        <p:txBody>
-          <a:bodyPr wrap="square" lIns="0" tIns="0" rIns="0" bIns="0" rtlCol="0" anchor="ctr"/>
-          <a:lstStyle/>
-          <a:p>
-            <a:pPr algn="ctr" indent="0" marL="0">
-              <a:buNone/>
-            </a:pPr>
-            <a:r>
-              <a:rPr lang="en-US" sz="1150" b="1" dirty="0">
-                <a:solidFill>
-                  <a:srgbClr val="FFFFFF"/>
-                </a:solidFill>
-                <a:latin typeface="Calibri" pitchFamily="34" charset="0"/>
-                <a:ea typeface="Calibri" pitchFamily="34" charset="-122"/>
-                <a:cs typeface="Calibri" pitchFamily="34" charset="-120"/>
-              </a:rPr>
-              <a:t>said</a:t>
-            </a:r>
-            <a:endParaRPr lang="en-US" sz="1150" dirty="0"/>
-          </a:p>
-        </p:txBody>
-      </p:sp>
-      <p:sp>
-        <p:nvSpPr>
-          <p:cNvPr id="44" name="Shape 42"/>
-          <p:cNvSpPr/>
-          <p:nvPr/>
-        </p:nvSpPr>
-        <p:spPr>
-          <a:xfrm>
-            <a:off x="10287000" y="4480560"/>
-            <a:ext cx="548640" cy="329184"/>
-          </a:xfrm>
-          <a:prstGeom prst="roundRect">
-            <a:avLst>
-              <a:gd name="adj" fmla="val 50000"/>
-            </a:avLst>
-          </a:prstGeom>
-          <a:solidFill>
-            <a:srgbClr val="5E7A5A"/>
-          </a:solidFill>
-          <a:ln w="12700">
-            <a:solidFill>
-              <a:srgbClr val="5E7A5A"/>
-            </a:solidFill>
-            <a:prstDash val="solid"/>
-          </a:ln>
-        </p:spPr>
-      </p:sp>
-      <p:sp>
-        <p:nvSpPr>
-          <p:cNvPr id="45" name="Text 43"/>
-          <p:cNvSpPr txBox="1"/>
-          <p:nvPr/>
-        </p:nvSpPr>
-        <p:spPr>
-          <a:xfrm>
-            <a:off x="10287000" y="4480560"/>
-            <a:ext cx="548640" cy="329184"/>
-          </a:xfrm>
-          <a:prstGeom prst="rect">
-            <a:avLst/>
-          </a:prstGeom>
-          <a:noFill/>
-          <a:ln/>
-        </p:spPr>
-        <p:txBody>
-          <a:bodyPr wrap="square" lIns="0" tIns="0" rIns="0" bIns="0" rtlCol="0" anchor="ctr"/>
-          <a:lstStyle/>
-          <a:p>
-            <a:pPr algn="ctr" indent="0" marL="0">
-              <a:buNone/>
-            </a:pPr>
-            <a:r>
-              <a:rPr lang="en-US" sz="1150" b="1" dirty="0">
-                <a:solidFill>
-                  <a:srgbClr val="FFFFFF"/>
-                </a:solidFill>
-                <a:latin typeface="Calibri" pitchFamily="34" charset="0"/>
-                <a:ea typeface="Calibri" pitchFamily="34" charset="-122"/>
-                <a:cs typeface="Calibri" pitchFamily="34" charset="-120"/>
-              </a:rPr>
-              <a:t>she</a:t>
-            </a:r>
-            <a:endParaRPr lang="en-US" sz="1150" dirty="0"/>
-          </a:p>
-        </p:txBody>
-      </p:sp>
-      <p:sp>
-        <p:nvSpPr>
-          <p:cNvPr id="46" name="Shape 44"/>
-          <p:cNvSpPr/>
-          <p:nvPr/>
-        </p:nvSpPr>
-        <p:spPr>
-          <a:xfrm>
-            <a:off x="9692640" y="4983480"/>
-            <a:ext cx="731520" cy="329184"/>
-          </a:xfrm>
-          <a:prstGeom prst="roundRect">
-            <a:avLst>
-              <a:gd name="adj" fmla="val 50000"/>
-            </a:avLst>
-          </a:prstGeom>
-          <a:solidFill>
-            <a:srgbClr val="5E7A5A"/>
-          </a:solidFill>
-          <a:ln w="12700">
-            <a:solidFill>
-              <a:srgbClr val="5E7A5A"/>
-            </a:solidFill>
-            <a:prstDash val="solid"/>
-          </a:ln>
-        </p:spPr>
-      </p:sp>
-      <p:sp>
-        <p:nvSpPr>
-          <p:cNvPr id="47" name="Text 45"/>
-          <p:cNvSpPr txBox="1"/>
-          <p:nvPr/>
-        </p:nvSpPr>
-        <p:spPr>
-          <a:xfrm>
-            <a:off x="9692640" y="4983480"/>
-            <a:ext cx="731520" cy="329184"/>
-          </a:xfrm>
-          <a:prstGeom prst="rect">
-            <a:avLst/>
-          </a:prstGeom>
-          <a:noFill/>
-          <a:ln/>
-        </p:spPr>
-        <p:txBody>
-          <a:bodyPr wrap="square" lIns="0" tIns="0" rIns="0" bIns="0" rtlCol="0" anchor="ctr"/>
-          <a:lstStyle/>
-          <a:p>
-            <a:pPr algn="ctr" indent="0" marL="0">
-              <a:buNone/>
-            </a:pPr>
-            <a:r>
-              <a:rPr lang="en-US" sz="1150" b="1" dirty="0">
-                <a:solidFill>
-                  <a:srgbClr val="FFFFFF"/>
-                </a:solidFill>
-                <a:latin typeface="Calibri" pitchFamily="34" charset="0"/>
-                <a:ea typeface="Calibri" pitchFamily="34" charset="-122"/>
-                <a:cs typeface="Calibri" pitchFamily="34" charset="-120"/>
-              </a:rPr>
-              <a:t>still</a:t>
-            </a:r>
-            <a:endParaRPr lang="en-US" sz="1150" dirty="0"/>
-          </a:p>
-        </p:txBody>
-      </p:sp>
-      <p:sp>
-        <p:nvSpPr>
-          <p:cNvPr id="48" name="Text 46"/>
-          <p:cNvSpPr txBox="1"/>
-          <p:nvPr/>
-        </p:nvSpPr>
-        <p:spPr>
-          <a:xfrm>
-            <a:off x="7086600" y="4983480"/>
-            <a:ext cx="2011680" cy="274320"/>
-          </a:xfrm>
-          <a:prstGeom prst="rect">
-            <a:avLst/>
-          </a:prstGeom>
-          <a:noFill/>
-          <a:ln/>
-        </p:spPr>
-        <p:txBody>
-          <a:bodyPr wrap="square" lIns="0" tIns="0" rIns="0" bIns="0" rtlCol="0" anchor="ctr"/>
-          <a:lstStyle/>
-          <a:p>
-            <a:pPr indent="0" marL="0">
-              <a:buNone/>
-            </a:pPr>
-            <a:r>
-              <a:rPr lang="en-US" sz="1000" i="1" dirty="0">
-                <a:solidFill>
-                  <a:srgbClr val="B5503F"/>
-                </a:solidFill>
-                <a:latin typeface="Calibri" pitchFamily="34" charset="0"/>
-                <a:ea typeface="Calibri" pitchFamily="34" charset="-122"/>
-                <a:cs typeface="Calibri" pitchFamily="34" charset="-120"/>
-              </a:rPr>
-              <a:t>région « spam »</a:t>
-            </a:r>
-            <a:endParaRPr lang="en-US" sz="1000" dirty="0"/>
-          </a:p>
-        </p:txBody>
-      </p:sp>
-      <p:sp>
-        <p:nvSpPr>
-          <p:cNvPr id="49" name="Text 47"/>
-          <p:cNvSpPr txBox="1"/>
-          <p:nvPr/>
-        </p:nvSpPr>
-        <p:spPr>
-          <a:xfrm>
-            <a:off x="9509760" y="5532120"/>
-            <a:ext cx="1828800" cy="274320"/>
-          </a:xfrm>
-          <a:prstGeom prst="rect">
-            <a:avLst/>
-          </a:prstGeom>
-          <a:noFill/>
-          <a:ln/>
-        </p:spPr>
-        <p:txBody>
-          <a:bodyPr wrap="square" lIns="0" tIns="0" rIns="0" bIns="0" rtlCol="0" anchor="ctr"/>
-          <a:lstStyle/>
-          <a:p>
-            <a:pPr algn="r" indent="0" marL="0">
-              <a:buNone/>
-            </a:pPr>
-            <a:r>
-              <a:rPr lang="en-US" sz="1000" i="1" dirty="0">
-                <a:solidFill>
-                  <a:srgbClr val="5E7A5A"/>
-                </a:solidFill>
-                <a:latin typeface="Calibri" pitchFamily="34" charset="0"/>
-                <a:ea typeface="Calibri" pitchFamily="34" charset="-122"/>
-                <a:cs typeface="Calibri" pitchFamily="34" charset="-120"/>
-              </a:rPr>
-              <a:t>région « ham »</a:t>
-            </a:r>
-            <a:endParaRPr lang="en-US" sz="1000" dirty="0"/>
-          </a:p>
-        </p:txBody>
-      </p:sp>
-      <p:sp>
-        <p:nvSpPr>
-          <p:cNvPr id="50" name="Text 48"/>
-          <p:cNvSpPr txBox="1"/>
-          <p:nvPr/>
-        </p:nvSpPr>
-        <p:spPr>
-          <a:xfrm>
-            <a:off x="7086600" y="5623560"/>
-            <a:ext cx="2743200" cy="274320"/>
-          </a:xfrm>
-          <a:prstGeom prst="rect">
-            <a:avLst/>
-          </a:prstGeom>
-          <a:noFill/>
-          <a:ln/>
-        </p:spPr>
-        <p:txBody>
-          <a:bodyPr wrap="square" lIns="0" tIns="0" rIns="0" bIns="0" rtlCol="0" anchor="ctr"/>
-          <a:lstStyle/>
-          <a:p>
-            <a:pPr indent="0" marL="0">
-              <a:buNone/>
-            </a:pPr>
-            <a:r>
-              <a:rPr lang="en-US" sz="950" i="1" dirty="0">
-                <a:solidFill>
-                  <a:srgbClr val="8A847A"/>
-                </a:solidFill>
-                <a:latin typeface="Calibri" pitchFamily="34" charset="0"/>
-                <a:ea typeface="Calibri" pitchFamily="34" charset="-122"/>
-                <a:cs typeface="Calibri" pitchFamily="34" charset="-120"/>
-              </a:rPr>
-              <a:t>schéma d'après la projection PCA du notebook</a:t>
-            </a:r>
-            <a:endParaRPr lang="en-US" sz="950" dirty="0"/>
           </a:p>
         </p:txBody>
       </p:sp>
@@ -12980,7 +11859,7 @@
                 <a:ea typeface="Calibri" pitchFamily="34" charset="-122"/>
                 <a:cs typeface="Calibri" pitchFamily="34" charset="-120"/>
               </a:rPr>
-              <a:t>ANNEXE · TRANSFER LEARNING</a:t>
+              <a:t>ANNEXE · PREUVE · MODÈLE 1</a:t>
             </a:r>
             <a:endParaRPr lang="en-US" sz="1200" dirty="0"/>
           </a:p>
@@ -13019,7 +11898,7 @@
                 <a:ea typeface="Cambria" pitchFamily="34" charset="-122"/>
                 <a:cs typeface="Cambria" pitchFamily="34" charset="-120"/>
               </a:rPr>
-              <a:t>Le fine-tuning : spécialiser un modèle qui sait déjà lire</a:t>
+              <a:t>Ce que la couche d'embedding a appris toute seule</a:t>
             </a:r>
             <a:endParaRPr lang="en-US" sz="3000" dirty="0"/>
           </a:p>
@@ -13097,7 +11976,7 @@
                 <a:ea typeface="Calibri" pitchFamily="34" charset="-122"/>
                 <a:cs typeface="Calibri" pitchFamily="34" charset="-120"/>
               </a:rPr>
-              <a:t>Annexe 2</a:t>
+              <a:t>Annexe 1</a:t>
             </a:r>
             <a:endParaRPr lang="en-US" sz="900" dirty="0"/>
           </a:p>
@@ -13105,57 +11984,18 @@
       </p:sp>
       <p:sp>
         <p:nvSpPr>
-          <p:cNvPr id="6" name="Text 4"/>
-          <p:cNvSpPr txBox="1"/>
-          <p:nvPr/>
-        </p:nvSpPr>
-        <p:spPr>
-          <a:xfrm>
-            <a:off x="777240" y="1737360"/>
-            <a:ext cx="10607040" cy="548640"/>
-          </a:xfrm>
-          <a:prstGeom prst="rect">
-            <a:avLst/>
-          </a:prstGeom>
-          <a:noFill/>
-          <a:ln/>
-        </p:spPr>
-        <p:txBody>
-          <a:bodyPr wrap="square" lIns="0" tIns="0" rIns="0" bIns="0" rtlCol="0" anchor="t"/>
-          <a:lstStyle/>
-          <a:p>
-            <a:pPr indent="0" marL="0">
-              <a:buNone/>
-            </a:pPr>
-            <a:r>
-              <a:rPr lang="en-US" sz="1400" dirty="0">
-                <a:solidFill>
-                  <a:srgbClr val="23201C"/>
-                </a:solidFill>
-                <a:latin typeface="Calibri" pitchFamily="34" charset="0"/>
-                <a:ea typeface="Calibri" pitchFamily="34" charset="-122"/>
-                <a:cs typeface="Calibri" pitchFamily="34" charset="-120"/>
-              </a:rPr>
-              <a:t>Avec 3 700 SMS on ne peut pas apprendre l'anglais. On part donc d'un modèle qui l'a déjà appris, et on l'ajuste à notre tâche.</a:t>
-            </a:r>
-            <a:endParaRPr lang="en-US" sz="1400" dirty="0"/>
-          </a:p>
-        </p:txBody>
-      </p:sp>
-      <p:sp>
-        <p:nvSpPr>
-          <p:cNvPr id="7" name="Shape 5"/>
+          <p:cNvPr id="6" name="Shape 4"/>
           <p:cNvSpPr/>
           <p:nvPr/>
         </p:nvSpPr>
         <p:spPr>
           <a:xfrm>
-            <a:off x="777240" y="2468880"/>
-            <a:ext cx="3383280" cy="2834640"/>
+            <a:off x="777240" y="1691640"/>
+            <a:ext cx="3931920" cy="4343400"/>
           </a:xfrm>
           <a:prstGeom prst="roundRect">
             <a:avLst>
-              <a:gd name="adj" fmla="val 3871"/>
+              <a:gd name="adj" fmla="val 2791"/>
             </a:avLst>
           </a:prstGeom>
           <a:solidFill>
@@ -13178,17 +12018,58 @@
       </p:sp>
       <p:sp>
         <p:nvSpPr>
+          <p:cNvPr id="7" name="Text 5"/>
+          <p:cNvSpPr txBox="1"/>
+          <p:nvPr/>
+        </p:nvSpPr>
+        <p:spPr>
+          <a:xfrm>
+            <a:off x="1051560" y="1874520"/>
+            <a:ext cx="3474720" cy="457200"/>
+          </a:xfrm>
+          <a:prstGeom prst="rect">
+            <a:avLst/>
+          </a:prstGeom>
+          <a:noFill/>
+          <a:ln/>
+        </p:spPr>
+        <p:txBody>
+          <a:bodyPr wrap="square" lIns="0" tIns="0" rIns="0" bIns="0" rtlCol="0" anchor="t"/>
+          <a:lstStyle/>
+          <a:p>
+            <a:pPr indent="0" marL="0">
+              <a:buNone/>
+            </a:pPr>
+            <a:r>
+              <a:rPr lang="en-US" sz="1200" b="1" dirty="0">
+                <a:solidFill>
+                  <a:srgbClr val="8A847A"/>
+                </a:solidFill>
+                <a:latin typeface="Calibri" pitchFamily="34" charset="0"/>
+                <a:ea typeface="Calibri" pitchFamily="34" charset="-122"/>
+                <a:cs typeface="Calibri" pitchFamily="34" charset="-120"/>
+              </a:rPr>
+              <a:t>Plus proches voisins (similarité cosinus) dans l'espace appris</a:t>
+            </a:r>
+            <a:endParaRPr lang="en-US" sz="1200" dirty="0"/>
+          </a:p>
+        </p:txBody>
+      </p:sp>
+      <p:sp>
+        <p:nvSpPr>
           <p:cNvPr id="8" name="Shape 6"/>
           <p:cNvSpPr/>
           <p:nvPr/>
         </p:nvSpPr>
         <p:spPr>
           <a:xfrm>
-            <a:off x="1051560" y="2697480"/>
-            <a:ext cx="457200" cy="457200"/>
-          </a:xfrm>
-          <a:prstGeom prst="ellipse">
-            <a:avLst/>
+            <a:off x="1051560" y="2423160"/>
+            <a:ext cx="868680" cy="310896"/>
+          </a:xfrm>
+          <a:prstGeom prst="roundRect">
+            <a:avLst>
+              <a:gd name="adj" fmla="val 50000"/>
+            </a:avLst>
           </a:prstGeom>
           <a:solidFill>
             <a:srgbClr val="B5503F"/>
@@ -13209,8 +12090,8 @@
         </p:nvSpPr>
         <p:spPr>
           <a:xfrm>
-            <a:off x="1051560" y="2697480"/>
-            <a:ext cx="457200" cy="457200"/>
+            <a:off x="1051560" y="2423160"/>
+            <a:ext cx="868680" cy="310896"/>
           </a:xfrm>
           <a:prstGeom prst="rect">
             <a:avLst/>
@@ -13226,7 +12107,7 @@
               <a:buNone/>
             </a:pPr>
             <a:r>
-              <a:rPr lang="en-US" sz="1400" b="1" dirty="0">
+              <a:rPr lang="en-US" sz="1100" b="1" dirty="0">
                 <a:solidFill>
                   <a:srgbClr val="FFFFFF"/>
                 </a:solidFill>
@@ -13234,9 +12115,9 @@
                 <a:ea typeface="Calibri" pitchFamily="34" charset="-122"/>
                 <a:cs typeface="Calibri" pitchFamily="34" charset="-120"/>
               </a:rPr>
-              <a:t>1</a:t>
-            </a:r>
-            <a:endParaRPr lang="en-US" sz="1400" dirty="0"/>
+              <a:t>prize</a:t>
+            </a:r>
+            <a:endParaRPr lang="en-US" sz="1100" dirty="0"/>
           </a:p>
         </p:txBody>
       </p:sp>
@@ -13248,8 +12129,8 @@
         </p:nvSpPr>
         <p:spPr>
           <a:xfrm>
-            <a:off x="1645920" y="2697480"/>
-            <a:ext cx="2286000" cy="457200"/>
+            <a:off x="2011680" y="2423160"/>
+            <a:ext cx="2514600" cy="310896"/>
           </a:xfrm>
           <a:prstGeom prst="rect">
             <a:avLst/>
@@ -13265,112 +12146,598 @@
               <a:buNone/>
             </a:pPr>
             <a:r>
-              <a:rPr lang="en-US" sz="1600" b="1" dirty="0">
+              <a:rPr lang="en-US" sz="1150" dirty="0">
                 <a:solidFill>
                   <a:srgbClr val="23201C"/>
                 </a:solidFill>
-                <a:latin typeface="Cambria" pitchFamily="34" charset="0"/>
-                <a:ea typeface="Cambria" pitchFamily="34" charset="-122"/>
-                <a:cs typeface="Cambria" pitchFamily="34" charset="-120"/>
-              </a:rPr>
-              <a:t>Pré-entraînement</a:t>
-            </a:r>
-            <a:endParaRPr lang="en-US" sz="1600" dirty="0"/>
-          </a:p>
-        </p:txBody>
-      </p:sp>
-      <p:sp>
-        <p:nvSpPr>
-          <p:cNvPr id="11" name="Text 9"/>
-          <p:cNvSpPr txBox="1"/>
-          <p:nvPr/>
-        </p:nvSpPr>
-        <p:spPr>
-          <a:xfrm>
-            <a:off x="1051560" y="3291840"/>
-            <a:ext cx="2834640" cy="1280160"/>
-          </a:xfrm>
-          <a:prstGeom prst="rect">
-            <a:avLst/>
-          </a:prstGeom>
-          <a:noFill/>
-          <a:ln/>
-        </p:spPr>
-        <p:txBody>
-          <a:bodyPr wrap="square" lIns="0" tIns="0" rIns="0" bIns="0" rtlCol="0" anchor="t"/>
-          <a:lstStyle/>
-          <a:p>
-            <a:pPr indent="0" marL="0">
-              <a:buNone/>
-            </a:pPr>
-            <a:r>
-              <a:rPr lang="en-US" sz="1200" dirty="0">
-                <a:solidFill>
-                  <a:srgbClr val="23201C"/>
-                </a:solidFill>
-                <a:latin typeface="Calibri" pitchFamily="34" charset="0"/>
-                <a:ea typeface="Calibri" pitchFamily="34" charset="-122"/>
-                <a:cs typeface="Calibri" pitchFamily="34" charset="-120"/>
-              </a:rPr>
-              <a:t>DistilBERT a appris à deviner des mots masqués dans des milliards de phrases. Il connaît la langue, la grammaire, le contexte.</a:t>
-            </a:r>
-            <a:endParaRPr lang="en-US" sz="1200" dirty="0"/>
-          </a:p>
-        </p:txBody>
-      </p:sp>
-      <p:sp>
-        <p:nvSpPr>
-          <p:cNvPr id="12" name="Text 10"/>
-          <p:cNvSpPr txBox="1"/>
-          <p:nvPr/>
-        </p:nvSpPr>
-        <p:spPr>
-          <a:xfrm>
-            <a:off x="1051560" y="4709160"/>
-            <a:ext cx="2834640" cy="457200"/>
-          </a:xfrm>
-          <a:prstGeom prst="rect">
-            <a:avLst/>
-          </a:prstGeom>
-          <a:noFill/>
-          <a:ln/>
-        </p:spPr>
-        <p:txBody>
-          <a:bodyPr wrap="square" lIns="0" tIns="0" rIns="0" bIns="0" rtlCol="0" anchor="t"/>
-          <a:lstStyle/>
-          <a:p>
-            <a:pPr indent="0" marL="0">
-              <a:buNone/>
-            </a:pPr>
-            <a:r>
-              <a:rPr lang="en-US" sz="1100" i="1" dirty="0">
-                <a:solidFill>
-                  <a:srgbClr val="B5503F"/>
-                </a:solidFill>
-                <a:latin typeface="Calibri" pitchFamily="34" charset="0"/>
-                <a:ea typeface="Calibri" pitchFamily="34" charset="-122"/>
-                <a:cs typeface="Calibri" pitchFamily="34" charset="-120"/>
-              </a:rPr>
-              <a:t>Fait une fois, par HuggingFace.</a:t>
-            </a:r>
-            <a:endParaRPr lang="en-US" sz="1100" dirty="0"/>
-          </a:p>
-        </p:txBody>
-      </p:sp>
-      <p:sp>
-        <p:nvSpPr>
-          <p:cNvPr id="13" name="Shape 11"/>
+                <a:latin typeface="Calibri" pitchFamily="34" charset="0"/>
+                <a:ea typeface="Calibri" pitchFamily="34" charset="-122"/>
+                <a:cs typeface="Calibri" pitchFamily="34" charset="-120"/>
+              </a:rPr>
+              <a:t>urgent, txt, mobile, stop</a:t>
+            </a:r>
+            <a:endParaRPr lang="en-US" sz="1150" dirty="0"/>
+          </a:p>
+        </p:txBody>
+      </p:sp>
+      <p:sp>
+        <p:nvSpPr>
+          <p:cNvPr id="11" name="Shape 9"/>
           <p:cNvSpPr/>
           <p:nvPr/>
         </p:nvSpPr>
         <p:spPr>
           <a:xfrm>
-            <a:off x="4389120" y="2468880"/>
-            <a:ext cx="3383280" cy="2834640"/>
+            <a:off x="1051560" y="2926080"/>
+            <a:ext cx="868680" cy="310896"/>
           </a:xfrm>
           <a:prstGeom prst="roundRect">
             <a:avLst>
-              <a:gd name="adj" fmla="val 3871"/>
+              <a:gd name="adj" fmla="val 50000"/>
+            </a:avLst>
+          </a:prstGeom>
+          <a:solidFill>
+            <a:srgbClr val="B5503F"/>
+          </a:solidFill>
+          <a:ln w="12700">
+            <a:solidFill>
+              <a:srgbClr val="B5503F"/>
+            </a:solidFill>
+            <a:prstDash val="solid"/>
+          </a:ln>
+        </p:spPr>
+      </p:sp>
+      <p:sp>
+        <p:nvSpPr>
+          <p:cNvPr id="12" name="Text 10"/>
+          <p:cNvSpPr txBox="1"/>
+          <p:nvPr/>
+        </p:nvSpPr>
+        <p:spPr>
+          <a:xfrm>
+            <a:off x="1051560" y="2926080"/>
+            <a:ext cx="868680" cy="310896"/>
+          </a:xfrm>
+          <a:prstGeom prst="rect">
+            <a:avLst/>
+          </a:prstGeom>
+          <a:noFill/>
+          <a:ln/>
+        </p:spPr>
+        <p:txBody>
+          <a:bodyPr wrap="square" lIns="0" tIns="0" rIns="0" bIns="0" rtlCol="0" anchor="ctr"/>
+          <a:lstStyle/>
+          <a:p>
+            <a:pPr algn="ctr" indent="0" marL="0">
+              <a:buNone/>
+            </a:pPr>
+            <a:r>
+              <a:rPr lang="en-US" sz="1100" b="1" dirty="0">
+                <a:solidFill>
+                  <a:srgbClr val="FFFFFF"/>
+                </a:solidFill>
+                <a:latin typeface="Calibri" pitchFamily="34" charset="0"/>
+                <a:ea typeface="Calibri" pitchFamily="34" charset="-122"/>
+                <a:cs typeface="Calibri" pitchFamily="34" charset="-120"/>
+              </a:rPr>
+              <a:t>win</a:t>
+            </a:r>
+            <a:endParaRPr lang="en-US" sz="1100" dirty="0"/>
+          </a:p>
+        </p:txBody>
+      </p:sp>
+      <p:sp>
+        <p:nvSpPr>
+          <p:cNvPr id="13" name="Text 11"/>
+          <p:cNvSpPr txBox="1"/>
+          <p:nvPr/>
+        </p:nvSpPr>
+        <p:spPr>
+          <a:xfrm>
+            <a:off x="2011680" y="2926080"/>
+            <a:ext cx="2514600" cy="310896"/>
+          </a:xfrm>
+          <a:prstGeom prst="rect">
+            <a:avLst/>
+          </a:prstGeom>
+          <a:noFill/>
+          <a:ln/>
+        </p:spPr>
+        <p:txBody>
+          <a:bodyPr wrap="square" lIns="0" tIns="0" rIns="0" bIns="0" rtlCol="0" anchor="ctr"/>
+          <a:lstStyle/>
+          <a:p>
+            <a:pPr indent="0" marL="0">
+              <a:buNone/>
+            </a:pPr>
+            <a:r>
+              <a:rPr lang="en-US" sz="1150" dirty="0">
+                <a:solidFill>
+                  <a:srgbClr val="23201C"/>
+                </a:solidFill>
+                <a:latin typeface="Calibri" pitchFamily="34" charset="0"/>
+                <a:ea typeface="Calibri" pitchFamily="34" charset="-122"/>
+                <a:cs typeface="Calibri" pitchFamily="34" charset="-120"/>
+              </a:rPr>
+              <a:t>txt, tone, mobile</a:t>
+            </a:r>
+            <a:endParaRPr lang="en-US" sz="1150" dirty="0"/>
+          </a:p>
+        </p:txBody>
+      </p:sp>
+      <p:sp>
+        <p:nvSpPr>
+          <p:cNvPr id="14" name="Shape 12"/>
+          <p:cNvSpPr/>
+          <p:nvPr/>
+        </p:nvSpPr>
+        <p:spPr>
+          <a:xfrm>
+            <a:off x="1051560" y="3429000"/>
+            <a:ext cx="868680" cy="310896"/>
+          </a:xfrm>
+          <a:prstGeom prst="roundRect">
+            <a:avLst>
+              <a:gd name="adj" fmla="val 50000"/>
+            </a:avLst>
+          </a:prstGeom>
+          <a:solidFill>
+            <a:srgbClr val="B5503F"/>
+          </a:solidFill>
+          <a:ln w="12700">
+            <a:solidFill>
+              <a:srgbClr val="B5503F"/>
+            </a:solidFill>
+            <a:prstDash val="solid"/>
+          </a:ln>
+        </p:spPr>
+      </p:sp>
+      <p:sp>
+        <p:nvSpPr>
+          <p:cNvPr id="15" name="Text 13"/>
+          <p:cNvSpPr txBox="1"/>
+          <p:nvPr/>
+        </p:nvSpPr>
+        <p:spPr>
+          <a:xfrm>
+            <a:off x="1051560" y="3429000"/>
+            <a:ext cx="868680" cy="310896"/>
+          </a:xfrm>
+          <a:prstGeom prst="rect">
+            <a:avLst/>
+          </a:prstGeom>
+          <a:noFill/>
+          <a:ln/>
+        </p:spPr>
+        <p:txBody>
+          <a:bodyPr wrap="square" lIns="0" tIns="0" rIns="0" bIns="0" rtlCol="0" anchor="ctr"/>
+          <a:lstStyle/>
+          <a:p>
+            <a:pPr algn="ctr" indent="0" marL="0">
+              <a:buNone/>
+            </a:pPr>
+            <a:r>
+              <a:rPr lang="en-US" sz="1100" b="1" dirty="0">
+                <a:solidFill>
+                  <a:srgbClr val="FFFFFF"/>
+                </a:solidFill>
+                <a:latin typeface="Calibri" pitchFamily="34" charset="0"/>
+                <a:ea typeface="Calibri" pitchFamily="34" charset="-122"/>
+                <a:cs typeface="Calibri" pitchFamily="34" charset="-120"/>
+              </a:rPr>
+              <a:t>free</a:t>
+            </a:r>
+            <a:endParaRPr lang="en-US" sz="1100" dirty="0"/>
+          </a:p>
+        </p:txBody>
+      </p:sp>
+      <p:sp>
+        <p:nvSpPr>
+          <p:cNvPr id="16" name="Text 14"/>
+          <p:cNvSpPr txBox="1"/>
+          <p:nvPr/>
+        </p:nvSpPr>
+        <p:spPr>
+          <a:xfrm>
+            <a:off x="2011680" y="3429000"/>
+            <a:ext cx="2514600" cy="310896"/>
+          </a:xfrm>
+          <a:prstGeom prst="rect">
+            <a:avLst/>
+          </a:prstGeom>
+          <a:noFill/>
+          <a:ln/>
+        </p:spPr>
+        <p:txBody>
+          <a:bodyPr wrap="square" lIns="0" tIns="0" rIns="0" bIns="0" rtlCol="0" anchor="ctr"/>
+          <a:lstStyle/>
+          <a:p>
+            <a:pPr indent="0" marL="0">
+              <a:buNone/>
+            </a:pPr>
+            <a:r>
+              <a:rPr lang="en-US" sz="1150" dirty="0">
+                <a:solidFill>
+                  <a:srgbClr val="23201C"/>
+                </a:solidFill>
+                <a:latin typeface="Calibri" pitchFamily="34" charset="0"/>
+                <a:ea typeface="Calibri" pitchFamily="34" charset="-122"/>
+                <a:cs typeface="Calibri" pitchFamily="34" charset="-120"/>
+              </a:rPr>
+              <a:t>call, guaranteed, new</a:t>
+            </a:r>
+            <a:endParaRPr lang="en-US" sz="1150" dirty="0"/>
+          </a:p>
+        </p:txBody>
+      </p:sp>
+      <p:sp>
+        <p:nvSpPr>
+          <p:cNvPr id="17" name="Shape 15"/>
+          <p:cNvSpPr/>
+          <p:nvPr/>
+        </p:nvSpPr>
+        <p:spPr>
+          <a:xfrm>
+            <a:off x="1051560" y="3931920"/>
+            <a:ext cx="868680" cy="310896"/>
+          </a:xfrm>
+          <a:prstGeom prst="roundRect">
+            <a:avLst>
+              <a:gd name="adj" fmla="val 50000"/>
+            </a:avLst>
+          </a:prstGeom>
+          <a:solidFill>
+            <a:srgbClr val="5E7A5A"/>
+          </a:solidFill>
+          <a:ln w="12700">
+            <a:solidFill>
+              <a:srgbClr val="5E7A5A"/>
+            </a:solidFill>
+            <a:prstDash val="solid"/>
+          </a:ln>
+        </p:spPr>
+      </p:sp>
+      <p:sp>
+        <p:nvSpPr>
+          <p:cNvPr id="18" name="Text 16"/>
+          <p:cNvSpPr txBox="1"/>
+          <p:nvPr/>
+        </p:nvSpPr>
+        <p:spPr>
+          <a:xfrm>
+            <a:off x="1051560" y="3931920"/>
+            <a:ext cx="868680" cy="310896"/>
+          </a:xfrm>
+          <a:prstGeom prst="rect">
+            <a:avLst/>
+          </a:prstGeom>
+          <a:noFill/>
+          <a:ln/>
+        </p:spPr>
+        <p:txBody>
+          <a:bodyPr wrap="square" lIns="0" tIns="0" rIns="0" bIns="0" rtlCol="0" anchor="ctr"/>
+          <a:lstStyle/>
+          <a:p>
+            <a:pPr algn="ctr" indent="0" marL="0">
+              <a:buNone/>
+            </a:pPr>
+            <a:r>
+              <a:rPr lang="en-US" sz="1100" b="1" dirty="0">
+                <a:solidFill>
+                  <a:srgbClr val="FFFFFF"/>
+                </a:solidFill>
+                <a:latin typeface="Calibri" pitchFamily="34" charset="0"/>
+                <a:ea typeface="Calibri" pitchFamily="34" charset="-122"/>
+                <a:cs typeface="Calibri" pitchFamily="34" charset="-120"/>
+              </a:rPr>
+              <a:t>ok</a:t>
+            </a:r>
+            <a:endParaRPr lang="en-US" sz="1100" dirty="0"/>
+          </a:p>
+        </p:txBody>
+      </p:sp>
+      <p:sp>
+        <p:nvSpPr>
+          <p:cNvPr id="19" name="Text 17"/>
+          <p:cNvSpPr txBox="1"/>
+          <p:nvPr/>
+        </p:nvSpPr>
+        <p:spPr>
+          <a:xfrm>
+            <a:off x="2011680" y="3931920"/>
+            <a:ext cx="2514600" cy="310896"/>
+          </a:xfrm>
+          <a:prstGeom prst="rect">
+            <a:avLst/>
+          </a:prstGeom>
+          <a:noFill/>
+          <a:ln/>
+        </p:spPr>
+        <p:txBody>
+          <a:bodyPr wrap="square" lIns="0" tIns="0" rIns="0" bIns="0" rtlCol="0" anchor="ctr"/>
+          <a:lstStyle/>
+          <a:p>
+            <a:pPr indent="0" marL="0">
+              <a:buNone/>
+            </a:pPr>
+            <a:r>
+              <a:rPr lang="en-US" sz="1150" dirty="0">
+                <a:solidFill>
+                  <a:srgbClr val="23201C"/>
+                </a:solidFill>
+                <a:latin typeface="Calibri" pitchFamily="34" charset="0"/>
+                <a:ea typeface="Calibri" pitchFamily="34" charset="-122"/>
+                <a:cs typeface="Calibri" pitchFamily="34" charset="-120"/>
+              </a:rPr>
+              <a:t>going, said, sorry, still</a:t>
+            </a:r>
+            <a:endParaRPr lang="en-US" sz="1150" dirty="0"/>
+          </a:p>
+        </p:txBody>
+      </p:sp>
+      <p:sp>
+        <p:nvSpPr>
+          <p:cNvPr id="20" name="Shape 18"/>
+          <p:cNvSpPr/>
+          <p:nvPr/>
+        </p:nvSpPr>
+        <p:spPr>
+          <a:xfrm>
+            <a:off x="1051560" y="4434840"/>
+            <a:ext cx="868680" cy="310896"/>
+          </a:xfrm>
+          <a:prstGeom prst="roundRect">
+            <a:avLst>
+              <a:gd name="adj" fmla="val 50000"/>
+            </a:avLst>
+          </a:prstGeom>
+          <a:solidFill>
+            <a:srgbClr val="5E7A5A"/>
+          </a:solidFill>
+          <a:ln w="12700">
+            <a:solidFill>
+              <a:srgbClr val="5E7A5A"/>
+            </a:solidFill>
+            <a:prstDash val="solid"/>
+          </a:ln>
+        </p:spPr>
+      </p:sp>
+      <p:sp>
+        <p:nvSpPr>
+          <p:cNvPr id="21" name="Text 19"/>
+          <p:cNvSpPr txBox="1"/>
+          <p:nvPr/>
+        </p:nvSpPr>
+        <p:spPr>
+          <a:xfrm>
+            <a:off x="1051560" y="4434840"/>
+            <a:ext cx="868680" cy="310896"/>
+          </a:xfrm>
+          <a:prstGeom prst="rect">
+            <a:avLst/>
+          </a:prstGeom>
+          <a:noFill/>
+          <a:ln/>
+        </p:spPr>
+        <p:txBody>
+          <a:bodyPr wrap="square" lIns="0" tIns="0" rIns="0" bIns="0" rtlCol="0" anchor="ctr"/>
+          <a:lstStyle/>
+          <a:p>
+            <a:pPr algn="ctr" indent="0" marL="0">
+              <a:buNone/>
+            </a:pPr>
+            <a:r>
+              <a:rPr lang="en-US" sz="1100" b="1" dirty="0">
+                <a:solidFill>
+                  <a:srgbClr val="FFFFFF"/>
+                </a:solidFill>
+                <a:latin typeface="Calibri" pitchFamily="34" charset="0"/>
+                <a:ea typeface="Calibri" pitchFamily="34" charset="-122"/>
+                <a:cs typeface="Calibri" pitchFamily="34" charset="-120"/>
+              </a:rPr>
+              <a:t>home</a:t>
+            </a:r>
+            <a:endParaRPr lang="en-US" sz="1100" dirty="0"/>
+          </a:p>
+        </p:txBody>
+      </p:sp>
+      <p:sp>
+        <p:nvSpPr>
+          <p:cNvPr id="22" name="Text 20"/>
+          <p:cNvSpPr txBox="1"/>
+          <p:nvPr/>
+        </p:nvSpPr>
+        <p:spPr>
+          <a:xfrm>
+            <a:off x="2011680" y="4434840"/>
+            <a:ext cx="2514600" cy="310896"/>
+          </a:xfrm>
+          <a:prstGeom prst="rect">
+            <a:avLst/>
+          </a:prstGeom>
+          <a:noFill/>
+          <a:ln/>
+        </p:spPr>
+        <p:txBody>
+          <a:bodyPr wrap="square" lIns="0" tIns="0" rIns="0" bIns="0" rtlCol="0" anchor="ctr"/>
+          <a:lstStyle/>
+          <a:p>
+            <a:pPr indent="0" marL="0">
+              <a:buNone/>
+            </a:pPr>
+            <a:r>
+              <a:rPr lang="en-US" sz="1150" dirty="0">
+                <a:solidFill>
+                  <a:srgbClr val="23201C"/>
+                </a:solidFill>
+                <a:latin typeface="Calibri" pitchFamily="34" charset="0"/>
+                <a:ea typeface="Calibri" pitchFamily="34" charset="-122"/>
+                <a:cs typeface="Calibri" pitchFamily="34" charset="-120"/>
+              </a:rPr>
+              <a:t>she, he, got</a:t>
+            </a:r>
+            <a:endParaRPr lang="en-US" sz="1150" dirty="0"/>
+          </a:p>
+        </p:txBody>
+      </p:sp>
+      <p:sp>
+        <p:nvSpPr>
+          <p:cNvPr id="23" name="Shape 21"/>
+          <p:cNvSpPr/>
+          <p:nvPr/>
+        </p:nvSpPr>
+        <p:spPr>
+          <a:xfrm>
+            <a:off x="1051560" y="4937760"/>
+            <a:ext cx="868680" cy="310896"/>
+          </a:xfrm>
+          <a:prstGeom prst="roundRect">
+            <a:avLst>
+              <a:gd name="adj" fmla="val 50000"/>
+            </a:avLst>
+          </a:prstGeom>
+          <a:solidFill>
+            <a:srgbClr val="5E7A5A"/>
+          </a:solidFill>
+          <a:ln w="12700">
+            <a:solidFill>
+              <a:srgbClr val="5E7A5A"/>
+            </a:solidFill>
+            <a:prstDash val="solid"/>
+          </a:ln>
+        </p:spPr>
+      </p:sp>
+      <p:sp>
+        <p:nvSpPr>
+          <p:cNvPr id="24" name="Text 22"/>
+          <p:cNvSpPr txBox="1"/>
+          <p:nvPr/>
+        </p:nvSpPr>
+        <p:spPr>
+          <a:xfrm>
+            <a:off x="1051560" y="4937760"/>
+            <a:ext cx="868680" cy="310896"/>
+          </a:xfrm>
+          <a:prstGeom prst="rect">
+            <a:avLst/>
+          </a:prstGeom>
+          <a:noFill/>
+          <a:ln/>
+        </p:spPr>
+        <p:txBody>
+          <a:bodyPr wrap="square" lIns="0" tIns="0" rIns="0" bIns="0" rtlCol="0" anchor="ctr"/>
+          <a:lstStyle/>
+          <a:p>
+            <a:pPr algn="ctr" indent="0" marL="0">
+              <a:buNone/>
+            </a:pPr>
+            <a:r>
+              <a:rPr lang="en-US" sz="1100" b="1" dirty="0">
+                <a:solidFill>
+                  <a:srgbClr val="FFFFFF"/>
+                </a:solidFill>
+                <a:latin typeface="Calibri" pitchFamily="34" charset="0"/>
+                <a:ea typeface="Calibri" pitchFamily="34" charset="-122"/>
+                <a:cs typeface="Calibri" pitchFamily="34" charset="-120"/>
+              </a:rPr>
+              <a:t>sorry</a:t>
+            </a:r>
+            <a:endParaRPr lang="en-US" sz="1100" dirty="0"/>
+          </a:p>
+        </p:txBody>
+      </p:sp>
+      <p:sp>
+        <p:nvSpPr>
+          <p:cNvPr id="25" name="Text 23"/>
+          <p:cNvSpPr txBox="1"/>
+          <p:nvPr/>
+        </p:nvSpPr>
+        <p:spPr>
+          <a:xfrm>
+            <a:off x="2011680" y="4937760"/>
+            <a:ext cx="2514600" cy="310896"/>
+          </a:xfrm>
+          <a:prstGeom prst="rect">
+            <a:avLst/>
+          </a:prstGeom>
+          <a:noFill/>
+          <a:ln/>
+        </p:spPr>
+        <p:txBody>
+          <a:bodyPr wrap="square" lIns="0" tIns="0" rIns="0" bIns="0" rtlCol="0" anchor="ctr"/>
+          <a:lstStyle/>
+          <a:p>
+            <a:pPr indent="0" marL="0">
+              <a:buNone/>
+            </a:pPr>
+            <a:r>
+              <a:rPr lang="en-US" sz="1150" dirty="0">
+                <a:solidFill>
+                  <a:srgbClr val="23201C"/>
+                </a:solidFill>
+                <a:latin typeface="Calibri" pitchFamily="34" charset="0"/>
+                <a:ea typeface="Calibri" pitchFamily="34" charset="-122"/>
+                <a:cs typeface="Calibri" pitchFamily="34" charset="-120"/>
+              </a:rPr>
+              <a:t>still, said, boy</a:t>
+            </a:r>
+            <a:endParaRPr lang="en-US" sz="1150" dirty="0"/>
+          </a:p>
+        </p:txBody>
+      </p:sp>
+      <p:sp>
+        <p:nvSpPr>
+          <p:cNvPr id="26" name="Text 24"/>
+          <p:cNvSpPr txBox="1"/>
+          <p:nvPr/>
+        </p:nvSpPr>
+        <p:spPr>
+          <a:xfrm>
+            <a:off x="1051560" y="5486400"/>
+            <a:ext cx="3474720" cy="502920"/>
+          </a:xfrm>
+          <a:prstGeom prst="rect">
+            <a:avLst/>
+          </a:prstGeom>
+          <a:noFill/>
+          <a:ln/>
+        </p:spPr>
+        <p:txBody>
+          <a:bodyPr wrap="square" lIns="0" tIns="0" rIns="0" bIns="0" rtlCol="0" anchor="t"/>
+          <a:lstStyle/>
+          <a:p>
+            <a:pPr indent="0" marL="0">
+              <a:buNone/>
+            </a:pPr>
+            <a:r>
+              <a:rPr lang="en-US" sz="1000" i="1" dirty="0">
+                <a:solidFill>
+                  <a:srgbClr val="8A847A"/>
+                </a:solidFill>
+                <a:latin typeface="Calibri" pitchFamily="34" charset="0"/>
+                <a:ea typeface="Calibri" pitchFamily="34" charset="-122"/>
+                <a:cs typeface="Calibri" pitchFamily="34" charset="-120"/>
+              </a:rPr>
+              <a:t>Aucun dictionnaire fourni : ces proximités émergent du seul objectif « ham ou spam ». Le jeton £ (montants) ressort aussi côté spam.</a:t>
+            </a:r>
+            <a:endParaRPr lang="en-US" sz="1000" dirty="0"/>
+          </a:p>
+        </p:txBody>
+      </p:sp>
+      <p:sp>
+        <p:nvSpPr>
+          <p:cNvPr id="27" name="Shape 25"/>
+          <p:cNvSpPr/>
+          <p:nvPr/>
+        </p:nvSpPr>
+        <p:spPr>
+          <a:xfrm>
+            <a:off x="4983480" y="1691640"/>
+            <a:ext cx="6400800" cy="4343400"/>
+          </a:xfrm>
+          <a:prstGeom prst="roundRect">
+            <a:avLst>
+              <a:gd name="adj" fmla="val 2526"/>
             </a:avLst>
           </a:prstGeom>
           <a:solidFill>
@@ -13393,39 +12760,14 @@
       </p:sp>
       <p:sp>
         <p:nvSpPr>
-          <p:cNvPr id="14" name="Shape 12"/>
-          <p:cNvSpPr/>
-          <p:nvPr/>
-        </p:nvSpPr>
-        <p:spPr>
-          <a:xfrm>
-            <a:off x="4663440" y="2697480"/>
-            <a:ext cx="457200" cy="457200"/>
-          </a:xfrm>
-          <a:prstGeom prst="ellipse">
-            <a:avLst/>
-          </a:prstGeom>
-          <a:solidFill>
-            <a:srgbClr val="B5503F"/>
-          </a:solidFill>
-          <a:ln w="12700">
-            <a:solidFill>
-              <a:srgbClr val="B5503F"/>
-            </a:solidFill>
-            <a:prstDash val="solid"/>
-          </a:ln>
-        </p:spPr>
-      </p:sp>
-      <p:sp>
-        <p:nvSpPr>
-          <p:cNvPr id="15" name="Text 13"/>
-          <p:cNvSpPr txBox="1"/>
-          <p:nvPr/>
-        </p:nvSpPr>
-        <p:spPr>
-          <a:xfrm>
-            <a:off x="4663440" y="2697480"/>
-            <a:ext cx="457200" cy="457200"/>
+          <p:cNvPr id="28" name="Text 26"/>
+          <p:cNvSpPr txBox="1"/>
+          <p:nvPr/>
+        </p:nvSpPr>
+        <p:spPr>
+          <a:xfrm>
+            <a:off x="5303520" y="1874520"/>
+            <a:ext cx="5852160" cy="320040"/>
           </a:xfrm>
           <a:prstGeom prst="rect">
             <a:avLst/>
@@ -13437,443 +12779,48 @@
           <a:bodyPr wrap="square" lIns="0" tIns="0" rIns="0" bIns="0" rtlCol="0" anchor="ctr"/>
           <a:lstStyle/>
           <a:p>
-            <a:pPr algn="ctr" indent="0" marL="0">
-              <a:buNone/>
-            </a:pPr>
-            <a:r>
-              <a:rPr lang="en-US" sz="1400" b="1" dirty="0">
-                <a:solidFill>
-                  <a:srgbClr val="FFFFFF"/>
-                </a:solidFill>
-                <a:latin typeface="Calibri" pitchFamily="34" charset="0"/>
-                <a:ea typeface="Calibri" pitchFamily="34" charset="-122"/>
-                <a:cs typeface="Calibri" pitchFamily="34" charset="-120"/>
-              </a:rPr>
-              <a:t>2</a:t>
-            </a:r>
-            <a:endParaRPr lang="en-US" sz="1400" dirty="0"/>
-          </a:p>
-        </p:txBody>
-      </p:sp>
-      <p:sp>
-        <p:nvSpPr>
-          <p:cNvPr id="16" name="Text 14"/>
-          <p:cNvSpPr txBox="1"/>
-          <p:nvPr/>
-        </p:nvSpPr>
-        <p:spPr>
-          <a:xfrm>
-            <a:off x="5257800" y="2697480"/>
-            <a:ext cx="2286000" cy="457200"/>
-          </a:xfrm>
-          <a:prstGeom prst="rect">
-            <a:avLst/>
-          </a:prstGeom>
-          <a:noFill/>
-          <a:ln/>
-        </p:spPr>
-        <p:txBody>
-          <a:bodyPr wrap="square" lIns="0" tIns="0" rIns="0" bIns="0" rtlCol="0" anchor="ctr"/>
-          <a:lstStyle/>
-          <a:p>
-            <a:pPr indent="0" marL="0">
-              <a:buNone/>
-            </a:pPr>
-            <a:r>
-              <a:rPr lang="en-US" sz="1600" b="1" dirty="0">
-                <a:solidFill>
-                  <a:srgbClr val="23201C"/>
-                </a:solidFill>
-                <a:latin typeface="Cambria" pitchFamily="34" charset="0"/>
-                <a:ea typeface="Cambria" pitchFamily="34" charset="-122"/>
-                <a:cs typeface="Cambria" pitchFamily="34" charset="-120"/>
-              </a:rPr>
-              <a:t>Ajout d'une tête</a:t>
-            </a:r>
-            <a:endParaRPr lang="en-US" sz="1600" dirty="0"/>
-          </a:p>
-        </p:txBody>
-      </p:sp>
-      <p:sp>
-        <p:nvSpPr>
-          <p:cNvPr id="17" name="Text 15"/>
-          <p:cNvSpPr txBox="1"/>
-          <p:nvPr/>
-        </p:nvSpPr>
-        <p:spPr>
-          <a:xfrm>
-            <a:off x="4663440" y="3291840"/>
-            <a:ext cx="2834640" cy="1280160"/>
-          </a:xfrm>
-          <a:prstGeom prst="rect">
-            <a:avLst/>
-          </a:prstGeom>
-          <a:noFill/>
-          <a:ln/>
-        </p:spPr>
-        <p:txBody>
-          <a:bodyPr wrap="square" lIns="0" tIns="0" rIns="0" bIns="0" rtlCol="0" anchor="t"/>
-          <a:lstStyle/>
-          <a:p>
-            <a:pPr indent="0" marL="0">
-              <a:buNone/>
-            </a:pPr>
-            <a:r>
-              <a:rPr lang="en-US" sz="1200" dirty="0">
-                <a:solidFill>
-                  <a:srgbClr val="23201C"/>
-                </a:solidFill>
-                <a:latin typeface="Calibri" pitchFamily="34" charset="0"/>
-                <a:ea typeface="Calibri" pitchFamily="34" charset="-122"/>
-                <a:cs typeface="Calibri" pitchFamily="34" charset="-120"/>
-              </a:rPr>
-              <a:t>On pose au-dessus une petite couche de décision à 2 sorties (ham / spam), initialisée au hasard.</a:t>
+            <a:pPr indent="0" marL="0">
+              <a:buNone/>
+            </a:pPr>
+            <a:r>
+              <a:rPr lang="en-US" sz="1200" b="1" dirty="0">
+                <a:solidFill>
+                  <a:srgbClr val="8A847A"/>
+                </a:solidFill>
+                <a:latin typeface="Calibri" pitchFamily="34" charset="0"/>
+                <a:ea typeface="Calibri" pitchFamily="34" charset="-122"/>
+                <a:cs typeface="Calibri" pitchFamily="34" charset="-120"/>
+              </a:rPr>
+              <a:t>Projection 2D (PCA) des 80 mots les plus fréquents, colorés par taux de spam</a:t>
             </a:r>
             <a:endParaRPr lang="en-US" sz="1200" dirty="0"/>
           </a:p>
         </p:txBody>
       </p:sp>
-      <p:sp>
-        <p:nvSpPr>
-          <p:cNvPr id="18" name="Text 16"/>
-          <p:cNvSpPr txBox="1"/>
-          <p:nvPr/>
-        </p:nvSpPr>
-        <p:spPr>
-          <a:xfrm>
-            <a:off x="4663440" y="4709160"/>
-            <a:ext cx="2834640" cy="457200"/>
-          </a:xfrm>
-          <a:prstGeom prst="rect">
-            <a:avLst/>
-          </a:prstGeom>
-          <a:noFill/>
-          <a:ln/>
-        </p:spPr>
-        <p:txBody>
-          <a:bodyPr wrap="square" lIns="0" tIns="0" rIns="0" bIns="0" rtlCol="0" anchor="t"/>
-          <a:lstStyle/>
-          <a:p>
-            <a:pPr indent="0" marL="0">
-              <a:buNone/>
-            </a:pPr>
-            <a:r>
-              <a:rPr lang="en-US" sz="1100" i="1" dirty="0">
-                <a:solidFill>
-                  <a:srgbClr val="B5503F"/>
-                </a:solidFill>
-                <a:latin typeface="Calibri" pitchFamily="34" charset="0"/>
-                <a:ea typeface="Calibri" pitchFamily="34" charset="-122"/>
-                <a:cs typeface="Calibri" pitchFamily="34" charset="-120"/>
-              </a:rPr>
-              <a:t>Le seul morceau vraiment nouveau.</a:t>
-            </a:r>
-            <a:endParaRPr lang="en-US" sz="1100" dirty="0"/>
-          </a:p>
-        </p:txBody>
-      </p:sp>
-      <p:sp>
-        <p:nvSpPr>
-          <p:cNvPr id="19" name="Shape 17"/>
-          <p:cNvSpPr/>
-          <p:nvPr/>
-        </p:nvSpPr>
-        <p:spPr>
-          <a:xfrm>
-            <a:off x="8001000" y="2468880"/>
-            <a:ext cx="3383280" cy="2834640"/>
-          </a:xfrm>
-          <a:prstGeom prst="roundRect">
-            <a:avLst>
-              <a:gd name="adj" fmla="val 3871"/>
-            </a:avLst>
-          </a:prstGeom>
-          <a:solidFill>
-            <a:srgbClr val="FFFFFF"/>
-          </a:solidFill>
-          <a:ln w="12700">
-            <a:solidFill>
-              <a:srgbClr val="E4DDD0"/>
-            </a:solidFill>
-            <a:prstDash val="solid"/>
-          </a:ln>
-          <a:effectLst>
-            <a:outerShdw sx="100000" sy="100000" kx="0" ky="0" algn="bl" rotWithShape="0" blurRad="88900" dist="25400" dir="5400000">
-              <a:srgbClr val="000000">
-                <a:alpha val="10000"/>
-              </a:srgbClr>
-            </a:outerShdw>
-          </a:effectLst>
-        </p:spPr>
-      </p:sp>
-      <p:sp>
-        <p:nvSpPr>
-          <p:cNvPr id="20" name="Shape 18"/>
-          <p:cNvSpPr/>
-          <p:nvPr/>
-        </p:nvSpPr>
-        <p:spPr>
-          <a:xfrm>
-            <a:off x="8275320" y="2697480"/>
-            <a:ext cx="457200" cy="457200"/>
-          </a:xfrm>
-          <a:prstGeom prst="ellipse">
-            <a:avLst/>
-          </a:prstGeom>
-          <a:solidFill>
-            <a:srgbClr val="B5503F"/>
-          </a:solidFill>
-          <a:ln w="12700">
-            <a:solidFill>
-              <a:srgbClr val="B5503F"/>
-            </a:solidFill>
-            <a:prstDash val="solid"/>
-          </a:ln>
-        </p:spPr>
-      </p:sp>
-      <p:sp>
-        <p:nvSpPr>
-          <p:cNvPr id="21" name="Text 19"/>
-          <p:cNvSpPr txBox="1"/>
-          <p:nvPr/>
-        </p:nvSpPr>
-        <p:spPr>
-          <a:xfrm>
-            <a:off x="8275320" y="2697480"/>
-            <a:ext cx="457200" cy="457200"/>
-          </a:xfrm>
-          <a:prstGeom prst="rect">
-            <a:avLst/>
-          </a:prstGeom>
-          <a:noFill/>
-          <a:ln/>
-        </p:spPr>
-        <p:txBody>
-          <a:bodyPr wrap="square" lIns="0" tIns="0" rIns="0" bIns="0" rtlCol="0" anchor="ctr"/>
-          <a:lstStyle/>
-          <a:p>
-            <a:pPr algn="ctr" indent="0" marL="0">
-              <a:buNone/>
-            </a:pPr>
-            <a:r>
-              <a:rPr lang="en-US" sz="1400" b="1" dirty="0">
-                <a:solidFill>
-                  <a:srgbClr val="FFFFFF"/>
-                </a:solidFill>
-                <a:latin typeface="Calibri" pitchFamily="34" charset="0"/>
-                <a:ea typeface="Calibri" pitchFamily="34" charset="-122"/>
-                <a:cs typeface="Calibri" pitchFamily="34" charset="-120"/>
-              </a:rPr>
-              <a:t>3</a:t>
-            </a:r>
-            <a:endParaRPr lang="en-US" sz="1400" dirty="0"/>
-          </a:p>
-        </p:txBody>
-      </p:sp>
-      <p:sp>
-        <p:nvSpPr>
-          <p:cNvPr id="22" name="Text 20"/>
-          <p:cNvSpPr txBox="1"/>
-          <p:nvPr/>
-        </p:nvSpPr>
-        <p:spPr>
-          <a:xfrm>
-            <a:off x="8869680" y="2697480"/>
-            <a:ext cx="2286000" cy="457200"/>
-          </a:xfrm>
-          <a:prstGeom prst="rect">
-            <a:avLst/>
-          </a:prstGeom>
-          <a:noFill/>
-          <a:ln/>
-        </p:spPr>
-        <p:txBody>
-          <a:bodyPr wrap="square" lIns="0" tIns="0" rIns="0" bIns="0" rtlCol="0" anchor="ctr"/>
-          <a:lstStyle/>
-          <a:p>
-            <a:pPr indent="0" marL="0">
-              <a:buNone/>
-            </a:pPr>
-            <a:r>
-              <a:rPr lang="en-US" sz="1600" b="1" dirty="0">
-                <a:solidFill>
-                  <a:srgbClr val="23201C"/>
-                </a:solidFill>
-                <a:latin typeface="Cambria" pitchFamily="34" charset="0"/>
-                <a:ea typeface="Cambria" pitchFamily="34" charset="-122"/>
-                <a:cs typeface="Cambria" pitchFamily="34" charset="-120"/>
-              </a:rPr>
-              <a:t>Ajustement fin</a:t>
-            </a:r>
-            <a:endParaRPr lang="en-US" sz="1600" dirty="0"/>
-          </a:p>
-        </p:txBody>
-      </p:sp>
-      <p:sp>
-        <p:nvSpPr>
-          <p:cNvPr id="23" name="Text 21"/>
-          <p:cNvSpPr txBox="1"/>
-          <p:nvPr/>
-        </p:nvSpPr>
-        <p:spPr>
-          <a:xfrm>
-            <a:off x="8275320" y="3291840"/>
-            <a:ext cx="2834640" cy="1280160"/>
-          </a:xfrm>
-          <a:prstGeom prst="rect">
-            <a:avLst/>
-          </a:prstGeom>
-          <a:noFill/>
-          <a:ln/>
-        </p:spPr>
-        <p:txBody>
-          <a:bodyPr wrap="square" lIns="0" tIns="0" rIns="0" bIns="0" rtlCol="0" anchor="t"/>
-          <a:lstStyle/>
-          <a:p>
-            <a:pPr indent="0" marL="0">
-              <a:buNone/>
-            </a:pPr>
-            <a:r>
-              <a:rPr lang="en-US" sz="1200" dirty="0">
-                <a:solidFill>
-                  <a:srgbClr val="23201C"/>
-                </a:solidFill>
-                <a:latin typeface="Calibri" pitchFamily="34" charset="0"/>
-                <a:ea typeface="Calibri" pitchFamily="34" charset="-122"/>
-                <a:cs typeface="Calibri" pitchFamily="34" charset="-120"/>
-              </a:rPr>
-              <a:t>On continue l'entraînement de tout le réseau sur nos SMS avec un pas très petit (lr 2e-5), 3 epochs, warm-up, meilleure epoch choisie sur la validation.</a:t>
-            </a:r>
-            <a:endParaRPr lang="en-US" sz="1200" dirty="0"/>
-          </a:p>
-        </p:txBody>
-      </p:sp>
-      <p:sp>
-        <p:nvSpPr>
-          <p:cNvPr id="24" name="Text 22"/>
-          <p:cNvSpPr txBox="1"/>
-          <p:nvPr/>
-        </p:nvSpPr>
-        <p:spPr>
-          <a:xfrm>
-            <a:off x="8275320" y="4709160"/>
-            <a:ext cx="2834640" cy="457200"/>
-          </a:xfrm>
-          <a:prstGeom prst="rect">
-            <a:avLst/>
-          </a:prstGeom>
-          <a:noFill/>
-          <a:ln/>
-        </p:spPr>
-        <p:txBody>
-          <a:bodyPr wrap="square" lIns="0" tIns="0" rIns="0" bIns="0" rtlCol="0" anchor="t"/>
-          <a:lstStyle/>
-          <a:p>
-            <a:pPr indent="0" marL="0">
-              <a:buNone/>
-            </a:pPr>
-            <a:r>
-              <a:rPr lang="en-US" sz="1100" i="1" dirty="0">
-                <a:solidFill>
-                  <a:srgbClr val="B5503F"/>
-                </a:solidFill>
-                <a:latin typeface="Calibri" pitchFamily="34" charset="0"/>
-                <a:ea typeface="Calibri" pitchFamily="34" charset="-122"/>
-                <a:cs typeface="Calibri" pitchFamily="34" charset="-120"/>
-              </a:rPr>
-              <a:t>Petit pas = on ajuste sans effacer.</a:t>
-            </a:r>
-            <a:endParaRPr lang="en-US" sz="1100" dirty="0"/>
-          </a:p>
-        </p:txBody>
-      </p:sp>
-      <p:sp>
-        <p:nvSpPr>
-          <p:cNvPr id="25" name="Shape 23"/>
-          <p:cNvSpPr/>
-          <p:nvPr/>
-        </p:nvSpPr>
-        <p:spPr>
-          <a:xfrm>
-            <a:off x="777240" y="5486400"/>
-            <a:ext cx="10607040" cy="685800"/>
-          </a:xfrm>
-          <a:prstGeom prst="roundRect">
-            <a:avLst>
-              <a:gd name="adj" fmla="val 16000"/>
-            </a:avLst>
-          </a:prstGeom>
-          <a:solidFill>
-            <a:srgbClr val="F3EDE2"/>
-          </a:solidFill>
-          <a:ln w="12700">
-            <a:solidFill>
-              <a:srgbClr val="E4DDD0"/>
-            </a:solidFill>
-            <a:prstDash val="solid"/>
-          </a:ln>
-          <a:effectLst>
-            <a:outerShdw sx="100000" sy="100000" kx="0" ky="0" algn="bl" rotWithShape="0" blurRad="88900" dist="25400" dir="5400000">
-              <a:srgbClr val="000000">
-                <a:alpha val="10000"/>
-              </a:srgbClr>
-            </a:outerShdw>
-          </a:effectLst>
-        </p:spPr>
-      </p:sp>
-      <p:sp>
-        <p:nvSpPr>
-          <p:cNvPr id="26" name="Text 24"/>
-          <p:cNvSpPr txBox="1"/>
-          <p:nvPr/>
-        </p:nvSpPr>
-        <p:spPr>
-          <a:xfrm>
-            <a:off x="1051560" y="5532120"/>
-            <a:ext cx="10058400" cy="594360"/>
-          </a:xfrm>
-          <a:prstGeom prst="rect">
-            <a:avLst/>
-          </a:prstGeom>
-          <a:noFill/>
-          <a:ln/>
-        </p:spPr>
-        <p:txBody>
-          <a:bodyPr wrap="square" lIns="0" tIns="0" rIns="0" bIns="0" rtlCol="0" anchor="ctr"/>
-          <a:lstStyle/>
-          <a:p>
-            <a:pPr indent="0" marL="0">
-              <a:buNone/>
-            </a:pPr>
-            <a:r>
-              <a:rPr lang="en-US" sz="1200" b="1" dirty="0">
-                <a:solidFill>
-                  <a:srgbClr val="23201C"/>
-                </a:solidFill>
-                <a:latin typeface="Calibri" pitchFamily="34" charset="0"/>
-                <a:ea typeface="Calibri" pitchFamily="34" charset="-122"/>
-                <a:cs typeface="Calibri" pitchFamily="34" charset="-120"/>
-              </a:rPr>
-              <a:t>Pourquoi pas « from scratch » ?  </a:t>
-            </a:r>
-            <a:pPr indent="0" marL="0">
-              <a:buNone/>
-            </a:pPr>
-            <a:r>
-              <a:rPr lang="en-US" sz="1200" dirty="0">
-                <a:solidFill>
-                  <a:srgbClr val="8A847A"/>
-                </a:solidFill>
-                <a:latin typeface="Calibri" pitchFamily="34" charset="0"/>
-                <a:ea typeface="Calibri" pitchFamily="34" charset="-122"/>
-                <a:cs typeface="Calibri" pitchFamily="34" charset="-120"/>
-              </a:rPr>
-              <a:t>Trop peu de données pour apprendre la langue ET la tâche. Le pré-entraînement apporte la langue ; nos SMS n'ont plus qu'à apporter la tâche. C'est ce transfert qui fait gagner +0,047 de F1 spam.</a:t>
-            </a:r>
-            <a:endParaRPr lang="en-US" sz="1200" dirty="0"/>
-          </a:p>
-        </p:txBody>
-      </p:sp>
+      <p:pic>
+        <p:nvPicPr>
+          <p:cNvPr id="29" name="Image 0" descr="preencoded.png">    </p:cNvPr>
+          <p:cNvPicPr>
+            <a:picLocks noChangeAspect="1"/>
+          </p:cNvPicPr>
+          <p:nvPr/>
+        </p:nvPicPr>
+        <p:blipFill>
+          <a:blip r:embed="rId1"/>
+          <a:stretch>
+            <a:fillRect/>
+          </a:stretch>
+        </p:blipFill>
+        <p:spPr>
+          <a:xfrm>
+            <a:off x="5424012" y="2240280"/>
+            <a:ext cx="5519736" cy="3703320"/>
+          </a:xfrm>
+          <a:prstGeom prst="rect">
+            <a:avLst/>
+          </a:prstGeom>
+        </p:spPr>
+      </p:pic>
     </p:spTree>
   </p:cSld>
   <p:clrMapOvr>

</xml_diff>